<commit_message>
Añadimos el fichero de teoria de la formación
</commit_message>
<xml_diff>
--- a/26Workshop.pptx
+++ b/26Workshop.pptx
@@ -5,15 +5,17 @@
     <p:sldMasterId id="2147483648" r:id="rId1"/>
   </p:sldMasterIdLst>
   <p:notesMasterIdLst>
-    <p:notesMasterId r:id="rId5"/>
+    <p:notesMasterId r:id="rId7"/>
   </p:notesMasterIdLst>
   <p:handoutMasterIdLst>
-    <p:handoutMasterId r:id="rId6"/>
+    <p:handoutMasterId r:id="rId8"/>
   </p:handoutMasterIdLst>
   <p:sldIdLst>
     <p:sldId id="256" r:id="rId2"/>
     <p:sldId id="257" r:id="rId3"/>
     <p:sldId id="258" r:id="rId4"/>
+    <p:sldId id="259" r:id="rId5"/>
+    <p:sldId id="260" r:id="rId6"/>
   </p:sldIdLst>
   <p:sldSz cx="24384000" cy="13716000"/>
   <p:notesSz cx="6858000" cy="9144000"/>
@@ -330,6 +332,9 @@
         </p15:guide>
       </p15:sldGuideLst>
     </p:ext>
+    <p:ext uri="{2D200454-40CA-4A62-9FC3-DE9A4176ACB9}">
+      <p15:notesGuideLst xmlns:p15="http://schemas.microsoft.com/office/powerpoint/2012/main"/>
+    </p:ext>
   </p:extLst>
 </p:presentation>
 </file>
@@ -2798,7 +2803,7 @@
           </a:ln>
           <a:extLst>
             <a:ext uri="{C572A759-6A51-4108-AA02-DFA0A04FC94B}">
-              <ma14:wrappingTextBoxFlag xmlns:ma14="http://schemas.microsoft.com/office/mac/drawingml/2011/main" xmlns:a14="http://schemas.microsoft.com/office/drawing/2010/main" xmlns:m="http://schemas.openxmlformats.org/officeDocument/2006/math" xmlns="" val="1"/>
+              <ma14:wrappingTextBoxFlag xmlns="" xmlns:m="http://schemas.openxmlformats.org/officeDocument/2006/math" xmlns:a14="http://schemas.microsoft.com/office/drawing/2010/main" xmlns:ma14="http://schemas.microsoft.com/office/mac/drawingml/2011/main" val="1"/>
             </a:ext>
           </a:extLst>
         </p:spPr>
@@ -3364,7 +3369,7 @@
           </a:ln>
           <a:extLst>
             <a:ext uri="{C572A759-6A51-4108-AA02-DFA0A04FC94B}">
-              <ma14:wrappingTextBoxFlag xmlns:ma14="http://schemas.microsoft.com/office/mac/drawingml/2011/main" xmlns:a14="http://schemas.microsoft.com/office/drawing/2010/main" xmlns:m="http://schemas.openxmlformats.org/officeDocument/2006/math" xmlns="" val="1"/>
+              <ma14:wrappingTextBoxFlag xmlns="" xmlns:m="http://schemas.openxmlformats.org/officeDocument/2006/math" xmlns:a14="http://schemas.microsoft.com/office/drawing/2010/main" xmlns:ma14="http://schemas.microsoft.com/office/mac/drawingml/2011/main" val="1"/>
             </a:ext>
           </a:extLst>
         </p:spPr>
@@ -3844,7 +3849,7 @@
           </a:ln>
           <a:extLst>
             <a:ext uri="{C572A759-6A51-4108-AA02-DFA0A04FC94B}">
-              <ma14:wrappingTextBoxFlag xmlns:ma14="http://schemas.microsoft.com/office/mac/drawingml/2011/main" xmlns:a14="http://schemas.microsoft.com/office/drawing/2010/main" xmlns:m="http://schemas.openxmlformats.org/officeDocument/2006/math" xmlns="" val="1"/>
+              <ma14:wrappingTextBoxFlag xmlns="" xmlns:m="http://schemas.openxmlformats.org/officeDocument/2006/math" xmlns:a14="http://schemas.microsoft.com/office/drawing/2010/main" xmlns:ma14="http://schemas.microsoft.com/office/mac/drawingml/2011/main" val="1"/>
             </a:ext>
           </a:extLst>
         </p:spPr>
@@ -4248,7 +4253,7 @@
           </a:ln>
           <a:extLst>
             <a:ext uri="{C572A759-6A51-4108-AA02-DFA0A04FC94B}">
-              <ma14:wrappingTextBoxFlag xmlns:ma14="http://schemas.microsoft.com/office/mac/drawingml/2011/main" xmlns:a14="http://schemas.microsoft.com/office/drawing/2010/main" xmlns:m="http://schemas.openxmlformats.org/officeDocument/2006/math" xmlns="" val="1"/>
+              <ma14:wrappingTextBoxFlag xmlns="" xmlns:m="http://schemas.openxmlformats.org/officeDocument/2006/math" xmlns:a14="http://schemas.microsoft.com/office/drawing/2010/main" xmlns:ma14="http://schemas.microsoft.com/office/mac/drawingml/2011/main" val="1"/>
             </a:ext>
           </a:extLst>
         </p:spPr>
@@ -7642,7 +7647,7 @@
           </a:ln>
           <a:extLst>
             <a:ext uri="{C572A759-6A51-4108-AA02-DFA0A04FC94B}">
-              <ma14:wrappingTextBoxFlag xmlns:ma14="http://schemas.microsoft.com/office/mac/drawingml/2011/main" xmlns:a14="http://schemas.microsoft.com/office/drawing/2010/main" xmlns:m="http://schemas.openxmlformats.org/officeDocument/2006/math" xmlns="" val="1"/>
+              <ma14:wrappingTextBoxFlag xmlns="" xmlns:m="http://schemas.openxmlformats.org/officeDocument/2006/math" xmlns:a14="http://schemas.microsoft.com/office/drawing/2010/main" xmlns:ma14="http://schemas.microsoft.com/office/mac/drawingml/2011/main" val="1"/>
             </a:ext>
           </a:extLst>
         </p:spPr>
@@ -7681,7 +7686,7 @@
           </a:ln>
           <a:extLst>
             <a:ext uri="{C572A759-6A51-4108-AA02-DFA0A04FC94B}">
-              <ma14:wrappingTextBoxFlag xmlns:ma14="http://schemas.microsoft.com/office/mac/drawingml/2011/main" xmlns:a14="http://schemas.microsoft.com/office/drawing/2010/main" xmlns:m="http://schemas.openxmlformats.org/officeDocument/2006/math" xmlns="" val="1"/>
+              <ma14:wrappingTextBoxFlag xmlns="" xmlns:m="http://schemas.openxmlformats.org/officeDocument/2006/math" xmlns:a14="http://schemas.microsoft.com/office/drawing/2010/main" xmlns:ma14="http://schemas.microsoft.com/office/mac/drawingml/2011/main" val="1"/>
             </a:ext>
           </a:extLst>
         </p:spPr>
@@ -8630,7 +8635,7 @@
           </a:prstGeom>
           <a:extLst>
             <a:ext uri="{C572A759-6A51-4108-AA02-DFA0A04FC94B}">
-              <ma14:wrappingTextBoxFlag xmlns:ma14="http://schemas.microsoft.com/office/mac/drawingml/2011/main" xmlns:a14="http://schemas.microsoft.com/office/drawing/2010/main" xmlns:m="http://schemas.openxmlformats.org/officeDocument/2006/math" xmlns="" val="1"/>
+              <ma14:wrappingTextBoxFlag xmlns="" xmlns:m="http://schemas.openxmlformats.org/officeDocument/2006/math" xmlns:a14="http://schemas.microsoft.com/office/drawing/2010/main" xmlns:ma14="http://schemas.microsoft.com/office/mac/drawingml/2011/main" val="1"/>
             </a:ext>
           </a:extLst>
         </p:spPr>
@@ -8738,7 +8743,7 @@
           </a:prstGeom>
           <a:extLst>
             <a:ext uri="{C572A759-6A51-4108-AA02-DFA0A04FC94B}">
-              <ma14:wrappingTextBoxFlag xmlns:ma14="http://schemas.microsoft.com/office/mac/drawingml/2011/main" xmlns:a14="http://schemas.microsoft.com/office/drawing/2010/main" xmlns:m="http://schemas.openxmlformats.org/officeDocument/2006/math" xmlns="" val="1"/>
+              <ma14:wrappingTextBoxFlag xmlns="" xmlns:m="http://schemas.openxmlformats.org/officeDocument/2006/math" xmlns:a14="http://schemas.microsoft.com/office/drawing/2010/main" xmlns:ma14="http://schemas.microsoft.com/office/mac/drawingml/2011/main" val="1"/>
             </a:ext>
           </a:extLst>
         </p:spPr>
@@ -8868,7 +8873,7 @@
           </a:prstGeom>
           <a:extLst>
             <a:ext uri="{C572A759-6A51-4108-AA02-DFA0A04FC94B}">
-              <ma14:wrappingTextBoxFlag xmlns:ma14="http://schemas.microsoft.com/office/mac/drawingml/2011/main" xmlns:a14="http://schemas.microsoft.com/office/drawing/2010/main" xmlns:m="http://schemas.openxmlformats.org/officeDocument/2006/math" xmlns="" val="1"/>
+              <ma14:wrappingTextBoxFlag xmlns="" xmlns:m="http://schemas.openxmlformats.org/officeDocument/2006/math" xmlns:a14="http://schemas.microsoft.com/office/drawing/2010/main" xmlns:ma14="http://schemas.microsoft.com/office/mac/drawingml/2011/main" val="1"/>
             </a:ext>
           </a:extLst>
         </p:spPr>
@@ -8902,7 +8907,7 @@
           </a:ln>
           <a:extLst>
             <a:ext uri="{C572A759-6A51-4108-AA02-DFA0A04FC94B}">
-              <ma14:wrappingTextBoxFlag xmlns:ma14="http://schemas.microsoft.com/office/mac/drawingml/2011/main" xmlns:a14="http://schemas.microsoft.com/office/drawing/2010/main" xmlns:m="http://schemas.openxmlformats.org/officeDocument/2006/math" xmlns="" val="1"/>
+              <ma14:wrappingTextBoxFlag xmlns="" xmlns:m="http://schemas.openxmlformats.org/officeDocument/2006/math" xmlns:a14="http://schemas.microsoft.com/office/drawing/2010/main" xmlns:ma14="http://schemas.microsoft.com/office/mac/drawingml/2011/main" val="1"/>
             </a:ext>
           </a:extLst>
         </p:spPr>
@@ -8983,6 +8988,139 @@
         </p:txBody>
       </p:sp>
     </p:spTree>
+  </p:cSld>
+  <p:clrMapOvr>
+    <a:masterClrMapping/>
+  </p:clrMapOvr>
+  <p:transition spd="med"/>
+</p:sld>
+</file>
+
+<file path=ppt/slides/slide4.xml><?xml version="1.0" encoding="utf-8"?>
+<p:sld xmlns:a="http://schemas.openxmlformats.org/drawingml/2006/main" xmlns:r="http://schemas.openxmlformats.org/officeDocument/2006/relationships" xmlns:p="http://schemas.openxmlformats.org/presentationml/2006/main">
+  <p:cSld>
+    <p:spTree>
+      <p:nvGrpSpPr>
+        <p:cNvPr id="1" name=""/>
+        <p:cNvGrpSpPr/>
+        <p:nvPr/>
+      </p:nvGrpSpPr>
+      <p:grpSpPr>
+        <a:xfrm>
+          <a:off x="0" y="0"/>
+          <a:ext cx="0" cy="0"/>
+          <a:chOff x="0" y="0"/>
+          <a:chExt cx="0" cy="0"/>
+        </a:xfrm>
+      </p:grpSpPr>
+      <p:sp>
+        <p:nvSpPr>
+          <p:cNvPr id="2" name="Título 1">
+            <a:extLst>
+              <a:ext uri="{FF2B5EF4-FFF2-40B4-BE49-F238E27FC236}">
+                <a16:creationId xmlns:a16="http://schemas.microsoft.com/office/drawing/2014/main" id="{AE0AC092-D7C9-1413-22C7-2BF4D0120034}"/>
+              </a:ext>
+            </a:extLst>
+          </p:cNvPr>
+          <p:cNvSpPr>
+            <a:spLocks noGrp="1"/>
+          </p:cNvSpPr>
+          <p:nvPr>
+            <p:ph type="title"/>
+          </p:nvPr>
+        </p:nvSpPr>
+        <p:spPr/>
+        <p:txBody>
+          <a:bodyPr/>
+          <a:lstStyle/>
+          <a:p>
+            <a:endParaRPr lang="es-ES"/>
+          </a:p>
+        </p:txBody>
+      </p:sp>
+    </p:spTree>
+    <p:extLst>
+      <p:ext uri="{BB962C8B-B14F-4D97-AF65-F5344CB8AC3E}">
+        <p14:creationId xmlns:p14="http://schemas.microsoft.com/office/powerpoint/2010/main" val="376384476"/>
+      </p:ext>
+    </p:extLst>
+  </p:cSld>
+  <p:clrMapOvr>
+    <a:masterClrMapping/>
+  </p:clrMapOvr>
+  <p:transition spd="med"/>
+</p:sld>
+</file>
+
+<file path=ppt/slides/slide5.xml><?xml version="1.0" encoding="utf-8"?>
+<p:sld xmlns:a="http://schemas.openxmlformats.org/drawingml/2006/main" xmlns:r="http://schemas.openxmlformats.org/officeDocument/2006/relationships" xmlns:p="http://schemas.openxmlformats.org/presentationml/2006/main">
+  <p:cSld>
+    <p:spTree>
+      <p:nvGrpSpPr>
+        <p:cNvPr id="1" name=""/>
+        <p:cNvGrpSpPr/>
+        <p:nvPr/>
+      </p:nvGrpSpPr>
+      <p:grpSpPr>
+        <a:xfrm>
+          <a:off x="0" y="0"/>
+          <a:ext cx="0" cy="0"/>
+          <a:chOff x="0" y="0"/>
+          <a:chExt cx="0" cy="0"/>
+        </a:xfrm>
+      </p:grpSpPr>
+      <p:pic>
+        <p:nvPicPr>
+          <p:cNvPr id="6" name="Imagen 5">
+            <a:extLst>
+              <a:ext uri="{FF2B5EF4-FFF2-40B4-BE49-F238E27FC236}">
+                <a16:creationId xmlns:a16="http://schemas.microsoft.com/office/drawing/2014/main" id="{941FC7A1-2CE2-A606-58B3-7BDE8EAC2CF1}"/>
+              </a:ext>
+            </a:extLst>
+          </p:cNvPr>
+          <p:cNvPicPr>
+            <a:picLocks noChangeAspect="1" noChangeArrowheads="1"/>
+          </p:cNvPicPr>
+          <p:nvPr/>
+        </p:nvPicPr>
+        <p:blipFill>
+          <a:blip r:embed="rId2">
+            <a:extLst>
+              <a:ext uri="{28A0092B-C50C-407E-A947-70E740481C1C}">
+                <a14:useLocalDpi xmlns:a14="http://schemas.microsoft.com/office/drawing/2010/main" val="0"/>
+              </a:ext>
+            </a:extLst>
+          </a:blip>
+          <a:stretch>
+            <a:fillRect/>
+          </a:stretch>
+        </p:blipFill>
+        <p:spPr bwMode="auto">
+          <a:xfrm>
+            <a:off x="5423960" y="136525"/>
+            <a:ext cx="13536081" cy="12387263"/>
+          </a:xfrm>
+          <a:prstGeom prst="rect">
+            <a:avLst/>
+          </a:prstGeom>
+          <a:noFill/>
+          <a:extLst>
+            <a:ext uri="{909E8E84-426E-40DD-AFC4-6F175D3DCCD1}">
+              <a14:hiddenFill xmlns:a14="http://schemas.microsoft.com/office/drawing/2010/main">
+                <a:solidFill>
+                  <a:srgbClr val="FFFFFF"/>
+                </a:solidFill>
+              </a14:hiddenFill>
+            </a:ext>
+          </a:extLst>
+        </p:spPr>
+      </p:pic>
+    </p:spTree>
+    <p:extLst>
+      <p:ext uri="{BB962C8B-B14F-4D97-AF65-F5344CB8AC3E}">
+        <p14:creationId xmlns:p14="http://schemas.microsoft.com/office/powerpoint/2010/main" val="2799412023"/>
+      </p:ext>
+    </p:extLst>
   </p:cSld>
   <p:clrMapOvr>
     <a:masterClrMapping/>

</xml_diff>

<commit_message>
Se añade el powerpoint guia del proyecto
</commit_message>
<xml_diff>
--- a/26Workshop.pptx
+++ b/26Workshop.pptx
@@ -5,19 +5,29 @@
     <p:sldMasterId id="2147483648" r:id="rId1"/>
   </p:sldMasterIdLst>
   <p:notesMasterIdLst>
-    <p:notesMasterId r:id="rId9"/>
+    <p:notesMasterId r:id="rId19"/>
   </p:notesMasterIdLst>
   <p:handoutMasterIdLst>
-    <p:handoutMasterId r:id="rId10"/>
+    <p:handoutMasterId r:id="rId20"/>
   </p:handoutMasterIdLst>
   <p:sldIdLst>
     <p:sldId id="256" r:id="rId2"/>
     <p:sldId id="260" r:id="rId3"/>
-    <p:sldId id="257" r:id="rId4"/>
-    <p:sldId id="261" r:id="rId5"/>
-    <p:sldId id="264" r:id="rId6"/>
-    <p:sldId id="265" r:id="rId7"/>
-    <p:sldId id="258" r:id="rId8"/>
+    <p:sldId id="274" r:id="rId4"/>
+    <p:sldId id="275" r:id="rId5"/>
+    <p:sldId id="276" r:id="rId6"/>
+    <p:sldId id="277" r:id="rId7"/>
+    <p:sldId id="266" r:id="rId8"/>
+    <p:sldId id="278" r:id="rId9"/>
+    <p:sldId id="282" r:id="rId10"/>
+    <p:sldId id="283" r:id="rId11"/>
+    <p:sldId id="284" r:id="rId12"/>
+    <p:sldId id="267" r:id="rId13"/>
+    <p:sldId id="285" r:id="rId14"/>
+    <p:sldId id="286" r:id="rId15"/>
+    <p:sldId id="287" r:id="rId16"/>
+    <p:sldId id="258" r:id="rId17"/>
+    <p:sldId id="261" r:id="rId18"/>
   </p:sldIdLst>
   <p:sldSz cx="24384000" cy="13716000"/>
   <p:notesSz cx="6858000" cy="9144000"/>
@@ -435,7 +445,7 @@
           <a:p>
             <a:fld id="{7F503C6F-49BD-47BC-9EDA-98E10EA3EBA1}" type="datetimeFigureOut">
               <a:rPr lang="es-ES" smtClean="0"/>
-              <a:t>14/4/26</a:t>
+              <a:t>14/04/2026</a:t>
             </a:fld>
             <a:endParaRPr lang="es-ES"/>
           </a:p>
@@ -1346,7 +1356,7 @@
           <p:nvPr userDrawn="1"/>
         </p:nvPicPr>
         <p:blipFill>
-          <a:blip r:embed="rId3">
+          <a:blip r:embed="rId3" cstate="print">
             <a:extLst>
               <a:ext uri="{28A0092B-C50C-407E-A947-70E740481C1C}">
                 <a14:useLocalDpi xmlns:a14="http://schemas.microsoft.com/office/drawing/2010/main" val="0"/>
@@ -1848,7 +1858,7 @@
           <p:nvPr userDrawn="1"/>
         </p:nvPicPr>
         <p:blipFill>
-          <a:blip r:embed="rId3">
+          <a:blip r:embed="rId3" cstate="print">
             <a:extLst>
               <a:ext uri="{28A0092B-C50C-407E-A947-70E740481C1C}">
                 <a14:useLocalDpi xmlns:a14="http://schemas.microsoft.com/office/drawing/2010/main" val="0"/>
@@ -2042,7 +2052,7 @@
           <p:nvPr userDrawn="1"/>
         </p:nvPicPr>
         <p:blipFill>
-          <a:blip r:embed="rId3">
+          <a:blip r:embed="rId3" cstate="print">
             <a:extLst>
               <a:ext uri="{28A0092B-C50C-407E-A947-70E740481C1C}">
                 <a14:useLocalDpi xmlns:a14="http://schemas.microsoft.com/office/drawing/2010/main" val="0"/>
@@ -2410,7 +2420,7 @@
           <p:nvPr userDrawn="1"/>
         </p:nvPicPr>
         <p:blipFill>
-          <a:blip r:embed="rId3">
+          <a:blip r:embed="rId3" cstate="print">
             <a:extLst>
               <a:ext uri="{28A0092B-C50C-407E-A947-70E740481C1C}">
                 <a14:useLocalDpi xmlns:a14="http://schemas.microsoft.com/office/drawing/2010/main" val="0"/>
@@ -2571,7 +2581,7 @@
           </a:ln>
           <a:extLst>
             <a:ext uri="{C572A759-6A51-4108-AA02-DFA0A04FC94B}">
-              <ma14:wrappingTextBoxFlag xmlns:ma14="http://schemas.microsoft.com/office/mac/drawingml/2011/main" xmlns:a14="http://schemas.microsoft.com/office/drawing/2010/main" xmlns:m="http://schemas.openxmlformats.org/officeDocument/2006/math" xmlns="" val="1"/>
+              <ma14:wrappingTextBoxFlag xmlns="" xmlns:m="http://schemas.openxmlformats.org/officeDocument/2006/math" xmlns:a14="http://schemas.microsoft.com/office/drawing/2010/main" xmlns:ma14="http://schemas.microsoft.com/office/mac/drawingml/2011/main" val="1"/>
             </a:ext>
           </a:extLst>
         </p:spPr>
@@ -2743,7 +2753,7 @@
           </a:ln>
           <a:extLst>
             <a:ext uri="{C572A759-6A51-4108-AA02-DFA0A04FC94B}">
-              <ma14:wrappingTextBoxFlag xmlns:ma14="http://schemas.microsoft.com/office/mac/drawingml/2011/main" xmlns:a14="http://schemas.microsoft.com/office/drawing/2010/main" xmlns:m="http://schemas.openxmlformats.org/officeDocument/2006/math" xmlns="" val="1"/>
+              <ma14:wrappingTextBoxFlag xmlns="" xmlns:m="http://schemas.openxmlformats.org/officeDocument/2006/math" xmlns:a14="http://schemas.microsoft.com/office/drawing/2010/main" xmlns:ma14="http://schemas.microsoft.com/office/mac/drawingml/2011/main" val="1"/>
             </a:ext>
           </a:extLst>
         </p:spPr>
@@ -2812,7 +2822,7 @@
           <p:nvPr userDrawn="1"/>
         </p:nvPicPr>
         <p:blipFill>
-          <a:blip r:embed="rId3">
+          <a:blip r:embed="rId3" cstate="print">
             <a:extLst>
               <a:ext uri="{28A0092B-C50C-407E-A947-70E740481C1C}">
                 <a14:useLocalDpi xmlns:a14="http://schemas.microsoft.com/office/drawing/2010/main" val="0"/>
@@ -3579,7 +3589,7 @@
           </a:ln>
           <a:extLst>
             <a:ext uri="{C572A759-6A51-4108-AA02-DFA0A04FC94B}">
-              <ma14:wrappingTextBoxFlag xmlns:ma14="http://schemas.microsoft.com/office/mac/drawingml/2011/main" xmlns:a14="http://schemas.microsoft.com/office/drawing/2010/main" xmlns:m="http://schemas.openxmlformats.org/officeDocument/2006/math" xmlns="" val="1"/>
+              <ma14:wrappingTextBoxFlag xmlns="" xmlns:m="http://schemas.openxmlformats.org/officeDocument/2006/math" xmlns:a14="http://schemas.microsoft.com/office/drawing/2010/main" xmlns:ma14="http://schemas.microsoft.com/office/mac/drawingml/2011/main" val="1"/>
             </a:ext>
           </a:extLst>
         </p:spPr>
@@ -4033,7 +4043,7 @@
           </a:ln>
           <a:extLst>
             <a:ext uri="{C572A759-6A51-4108-AA02-DFA0A04FC94B}">
-              <ma14:wrappingTextBoxFlag xmlns:ma14="http://schemas.microsoft.com/office/mac/drawingml/2011/main" xmlns:a14="http://schemas.microsoft.com/office/drawing/2010/main" xmlns:m="http://schemas.openxmlformats.org/officeDocument/2006/math" xmlns="" val="1"/>
+              <ma14:wrappingTextBoxFlag xmlns="" xmlns:m="http://schemas.openxmlformats.org/officeDocument/2006/math" xmlns:a14="http://schemas.microsoft.com/office/drawing/2010/main" xmlns:ma14="http://schemas.microsoft.com/office/mac/drawingml/2011/main" val="1"/>
             </a:ext>
           </a:extLst>
         </p:spPr>
@@ -5248,7 +5258,7 @@
           <p:nvPr userDrawn="1"/>
         </p:nvPicPr>
         <p:blipFill>
-          <a:blip r:embed="rId3">
+          <a:blip r:embed="rId3" cstate="print">
             <a:extLst>
               <a:ext uri="{28A0092B-C50C-407E-A947-70E740481C1C}">
                 <a14:useLocalDpi xmlns:a14="http://schemas.microsoft.com/office/drawing/2010/main" val="0"/>
@@ -5598,7 +5608,7 @@
           <p:nvPr userDrawn="1"/>
         </p:nvPicPr>
         <p:blipFill>
-          <a:blip r:embed="rId3">
+          <a:blip r:embed="rId3" cstate="print">
             <a:extLst>
               <a:ext uri="{28A0092B-C50C-407E-A947-70E740481C1C}">
                 <a14:useLocalDpi xmlns:a14="http://schemas.microsoft.com/office/drawing/2010/main" val="0"/>
@@ -6132,7 +6142,7 @@
           <p:nvPr userDrawn="1"/>
         </p:nvPicPr>
         <p:blipFill>
-          <a:blip r:embed="rId3">
+          <a:blip r:embed="rId3" cstate="print">
             <a:extLst>
               <a:ext uri="{28A0092B-C50C-407E-A947-70E740481C1C}">
                 <a14:useLocalDpi xmlns:a14="http://schemas.microsoft.com/office/drawing/2010/main" val="0"/>
@@ -6221,7 +6231,7 @@
           </a:ln>
           <a:extLst>
             <a:ext uri="{C572A759-6A51-4108-AA02-DFA0A04FC94B}">
-              <ma14:wrappingTextBoxFlag xmlns:ma14="http://schemas.microsoft.com/office/mac/drawingml/2011/main" xmlns:a14="http://schemas.microsoft.com/office/drawing/2010/main" xmlns:m="http://schemas.openxmlformats.org/officeDocument/2006/math" xmlns="" val="1"/>
+              <ma14:wrappingTextBoxFlag xmlns="" xmlns:m="http://schemas.openxmlformats.org/officeDocument/2006/math" xmlns:a14="http://schemas.microsoft.com/office/drawing/2010/main" xmlns:ma14="http://schemas.microsoft.com/office/mac/drawingml/2011/main" val="1"/>
             </a:ext>
           </a:extLst>
         </p:spPr>
@@ -6260,7 +6270,7 @@
           </a:ln>
           <a:extLst>
             <a:ext uri="{C572A759-6A51-4108-AA02-DFA0A04FC94B}">
-              <ma14:wrappingTextBoxFlag xmlns:ma14="http://schemas.microsoft.com/office/mac/drawingml/2011/main" xmlns:a14="http://schemas.microsoft.com/office/drawing/2010/main" xmlns:m="http://schemas.openxmlformats.org/officeDocument/2006/math" xmlns="" val="1"/>
+              <ma14:wrappingTextBoxFlag xmlns="" xmlns:m="http://schemas.openxmlformats.org/officeDocument/2006/math" xmlns:a14="http://schemas.microsoft.com/office/drawing/2010/main" xmlns:ma14="http://schemas.microsoft.com/office/mac/drawingml/2011/main" val="1"/>
             </a:ext>
           </a:extLst>
         </p:spPr>
@@ -7202,7 +7212,7 @@
           </a:prstGeom>
           <a:extLst>
             <a:ext uri="{C572A759-6A51-4108-AA02-DFA0A04FC94B}">
-              <ma14:wrappingTextBoxFlag xmlns:ma14="http://schemas.microsoft.com/office/mac/drawingml/2011/main" xmlns:a14="http://schemas.microsoft.com/office/drawing/2010/main" xmlns:m="http://schemas.openxmlformats.org/officeDocument/2006/math" xmlns="" val="1"/>
+              <ma14:wrappingTextBoxFlag xmlns="" xmlns:m="http://schemas.openxmlformats.org/officeDocument/2006/math" xmlns:a14="http://schemas.microsoft.com/office/drawing/2010/main" xmlns:ma14="http://schemas.microsoft.com/office/mac/drawingml/2011/main" val="1"/>
             </a:ext>
           </a:extLst>
         </p:spPr>
@@ -7414,6 +7424,1423 @@
         </p:txBody>
       </p:sp>
     </p:spTree>
+  </p:cSld>
+  <p:clrMapOvr>
+    <a:masterClrMapping/>
+  </p:clrMapOvr>
+  <p:transition spd="med"/>
+</p:sld>
+</file>
+
+<file path=ppt/slides/slide10.xml><?xml version="1.0" encoding="utf-8"?>
+<p:sld xmlns:a="http://schemas.openxmlformats.org/drawingml/2006/main" xmlns:r="http://schemas.openxmlformats.org/officeDocument/2006/relationships" xmlns:p="http://schemas.openxmlformats.org/presentationml/2006/main">
+  <p:cSld>
+    <p:spTree>
+      <p:nvGrpSpPr>
+        <p:cNvPr id="1" name="">
+          <a:extLst>
+            <a:ext uri="{FF2B5EF4-FFF2-40B4-BE49-F238E27FC236}">
+              <a16:creationId xmlns:a16="http://schemas.microsoft.com/office/drawing/2014/main" id="{7AFB1616-6718-B9D5-223D-65F15C5BAC39}"/>
+            </a:ext>
+          </a:extLst>
+        </p:cNvPr>
+        <p:cNvGrpSpPr/>
+        <p:nvPr/>
+      </p:nvGrpSpPr>
+      <p:grpSpPr>
+        <a:xfrm>
+          <a:off x="0" y="0"/>
+          <a:ext cx="0" cy="0"/>
+          <a:chOff x="0" y="0"/>
+          <a:chExt cx="0" cy="0"/>
+        </a:xfrm>
+      </p:grpSpPr>
+      <p:sp>
+        <p:nvSpPr>
+          <p:cNvPr id="26" name="CuadroTexto 25">
+            <a:extLst>
+              <a:ext uri="{FF2B5EF4-FFF2-40B4-BE49-F238E27FC236}">
+                <a16:creationId xmlns:a16="http://schemas.microsoft.com/office/drawing/2014/main" id="{DA140309-F701-0D0F-3299-6A55CD01E524}"/>
+              </a:ext>
+            </a:extLst>
+          </p:cNvPr>
+          <p:cNvSpPr txBox="1"/>
+          <p:nvPr/>
+        </p:nvSpPr>
+        <p:spPr>
+          <a:xfrm>
+            <a:off x="1417814" y="3879559"/>
+            <a:ext cx="1905444" cy="1719852"/>
+          </a:xfrm>
+          <a:prstGeom prst="rect">
+            <a:avLst/>
+          </a:prstGeom>
+        </p:spPr>
+        <p:txBody>
+          <a:bodyPr vert="horz" wrap="square" lIns="91440" tIns="45720" rIns="91440" bIns="45720" rtlCol="0">
+            <a:noAutofit/>
+          </a:bodyPr>
+          <a:lstStyle/>
+          <a:p>
+            <a:r>
+              <a:rPr lang="es-ES" sz="8800" b="1" dirty="0">
+                <a:solidFill>
+                  <a:srgbClr val="3479BB"/>
+                </a:solidFill>
+                <a:latin typeface="Montserrat" pitchFamily="2" charset="77"/>
+              </a:rPr>
+              <a:t>1. </a:t>
+            </a:r>
+          </a:p>
+        </p:txBody>
+      </p:sp>
+      <p:sp>
+        <p:nvSpPr>
+          <p:cNvPr id="46" name="CuadroTexto 45">
+            <a:extLst>
+              <a:ext uri="{FF2B5EF4-FFF2-40B4-BE49-F238E27FC236}">
+                <a16:creationId xmlns:a16="http://schemas.microsoft.com/office/drawing/2014/main" id="{678EB100-5C5A-6CCE-3846-6D5093E389E9}"/>
+              </a:ext>
+            </a:extLst>
+          </p:cNvPr>
+          <p:cNvSpPr txBox="1"/>
+          <p:nvPr/>
+        </p:nvSpPr>
+        <p:spPr>
+          <a:xfrm>
+            <a:off x="2783840" y="7256664"/>
+            <a:ext cx="20706080" cy="1719852"/>
+          </a:xfrm>
+          <a:prstGeom prst="rect">
+            <a:avLst/>
+          </a:prstGeom>
+        </p:spPr>
+        <p:txBody>
+          <a:bodyPr vert="horz" wrap="square" lIns="91440" tIns="45720" rIns="91440" bIns="45720" rtlCol="0">
+            <a:noAutofit/>
+          </a:bodyPr>
+          <a:lstStyle/>
+          <a:p>
+            <a:pPr algn="r"/>
+            <a:r>
+              <a:rPr lang="es-ES" sz="11500" b="1" dirty="0">
+                <a:solidFill>
+                  <a:srgbClr val="F2F2F2"/>
+                </a:solidFill>
+                <a:latin typeface="Montserrat" pitchFamily="2" charset="77"/>
+              </a:rPr>
+              <a:t>7. Evaluación e interpretabilidad de modelos</a:t>
+            </a:r>
+          </a:p>
+        </p:txBody>
+      </p:sp>
+    </p:spTree>
+    <p:extLst>
+      <p:ext uri="{BB962C8B-B14F-4D97-AF65-F5344CB8AC3E}">
+        <p14:creationId xmlns:p14="http://schemas.microsoft.com/office/powerpoint/2010/main" val="2417975974"/>
+      </p:ext>
+    </p:extLst>
+  </p:cSld>
+  <p:clrMapOvr>
+    <a:masterClrMapping/>
+  </p:clrMapOvr>
+  <p:transition spd="med"/>
+</p:sld>
+</file>
+
+<file path=ppt/slides/slide11.xml><?xml version="1.0" encoding="utf-8"?>
+<p:sld xmlns:a="http://schemas.openxmlformats.org/drawingml/2006/main" xmlns:r="http://schemas.openxmlformats.org/officeDocument/2006/relationships" xmlns:p="http://schemas.openxmlformats.org/presentationml/2006/main">
+  <p:cSld>
+    <p:spTree>
+      <p:nvGrpSpPr>
+        <p:cNvPr id="1" name="">
+          <a:extLst>
+            <a:ext uri="{FF2B5EF4-FFF2-40B4-BE49-F238E27FC236}">
+              <a16:creationId xmlns:a16="http://schemas.microsoft.com/office/drawing/2014/main" id="{F5FDDA47-6697-3C80-BDBE-FC42834F1C2C}"/>
+            </a:ext>
+          </a:extLst>
+        </p:cNvPr>
+        <p:cNvGrpSpPr/>
+        <p:nvPr/>
+      </p:nvGrpSpPr>
+      <p:grpSpPr>
+        <a:xfrm>
+          <a:off x="0" y="0"/>
+          <a:ext cx="0" cy="0"/>
+          <a:chOff x="0" y="0"/>
+          <a:chExt cx="0" cy="0"/>
+        </a:xfrm>
+      </p:grpSpPr>
+      <p:sp>
+        <p:nvSpPr>
+          <p:cNvPr id="26" name="CuadroTexto 25">
+            <a:extLst>
+              <a:ext uri="{FF2B5EF4-FFF2-40B4-BE49-F238E27FC236}">
+                <a16:creationId xmlns:a16="http://schemas.microsoft.com/office/drawing/2014/main" id="{02FFE846-0258-B8A2-4A6A-2E8BF8D85184}"/>
+              </a:ext>
+            </a:extLst>
+          </p:cNvPr>
+          <p:cNvSpPr txBox="1"/>
+          <p:nvPr/>
+        </p:nvSpPr>
+        <p:spPr>
+          <a:xfrm>
+            <a:off x="1417814" y="3879559"/>
+            <a:ext cx="1905444" cy="1719852"/>
+          </a:xfrm>
+          <a:prstGeom prst="rect">
+            <a:avLst/>
+          </a:prstGeom>
+        </p:spPr>
+        <p:txBody>
+          <a:bodyPr vert="horz" wrap="square" lIns="91440" tIns="45720" rIns="91440" bIns="45720" rtlCol="0">
+            <a:noAutofit/>
+          </a:bodyPr>
+          <a:lstStyle/>
+          <a:p>
+            <a:r>
+              <a:rPr lang="es-ES" sz="8800" b="1" dirty="0">
+                <a:solidFill>
+                  <a:srgbClr val="3479BB"/>
+                </a:solidFill>
+                <a:latin typeface="Montserrat" pitchFamily="2" charset="77"/>
+              </a:rPr>
+              <a:t>1. </a:t>
+            </a:r>
+          </a:p>
+        </p:txBody>
+      </p:sp>
+      <p:sp>
+        <p:nvSpPr>
+          <p:cNvPr id="46" name="CuadroTexto 45">
+            <a:extLst>
+              <a:ext uri="{FF2B5EF4-FFF2-40B4-BE49-F238E27FC236}">
+                <a16:creationId xmlns:a16="http://schemas.microsoft.com/office/drawing/2014/main" id="{C630A510-7B4D-7277-5C86-7400383B33C4}"/>
+              </a:ext>
+            </a:extLst>
+          </p:cNvPr>
+          <p:cNvSpPr txBox="1"/>
+          <p:nvPr/>
+        </p:nvSpPr>
+        <p:spPr>
+          <a:xfrm>
+            <a:off x="2783840" y="7256664"/>
+            <a:ext cx="20706080" cy="1719852"/>
+          </a:xfrm>
+          <a:prstGeom prst="rect">
+            <a:avLst/>
+          </a:prstGeom>
+        </p:spPr>
+        <p:txBody>
+          <a:bodyPr vert="horz" wrap="square" lIns="91440" tIns="45720" rIns="91440" bIns="45720" rtlCol="0">
+            <a:noAutofit/>
+          </a:bodyPr>
+          <a:lstStyle/>
+          <a:p>
+            <a:pPr algn="r"/>
+            <a:r>
+              <a:rPr lang="es-ES" sz="11500" b="1" dirty="0">
+                <a:solidFill>
+                  <a:srgbClr val="F2F2F2"/>
+                </a:solidFill>
+                <a:latin typeface="Montserrat" pitchFamily="2" charset="77"/>
+              </a:rPr>
+              <a:t>8. Deep </a:t>
+            </a:r>
+            <a:r>
+              <a:rPr lang="es-ES" sz="11500" b="1" dirty="0" err="1">
+                <a:solidFill>
+                  <a:srgbClr val="F2F2F2"/>
+                </a:solidFill>
+                <a:latin typeface="Montserrat" pitchFamily="2" charset="77"/>
+              </a:rPr>
+              <a:t>Learning</a:t>
+            </a:r>
+            <a:r>
+              <a:rPr lang="es-ES" sz="11500" b="1" dirty="0">
+                <a:solidFill>
+                  <a:srgbClr val="F2F2F2"/>
+                </a:solidFill>
+                <a:latin typeface="Montserrat" pitchFamily="2" charset="77"/>
+              </a:rPr>
+              <a:t>:</a:t>
+            </a:r>
+          </a:p>
+          <a:p>
+            <a:pPr algn="r"/>
+            <a:r>
+              <a:rPr lang="es-ES" sz="11500" b="1" dirty="0">
+                <a:solidFill>
+                  <a:srgbClr val="F2F2F2"/>
+                </a:solidFill>
+                <a:latin typeface="Montserrat" pitchFamily="2" charset="77"/>
+              </a:rPr>
+              <a:t>Artificial Neuronal Network (ANN)</a:t>
+            </a:r>
+          </a:p>
+        </p:txBody>
+      </p:sp>
+    </p:spTree>
+    <p:extLst>
+      <p:ext uri="{BB962C8B-B14F-4D97-AF65-F5344CB8AC3E}">
+        <p14:creationId xmlns:p14="http://schemas.microsoft.com/office/powerpoint/2010/main" val="1116637264"/>
+      </p:ext>
+    </p:extLst>
+  </p:cSld>
+  <p:clrMapOvr>
+    <a:masterClrMapping/>
+  </p:clrMapOvr>
+  <p:transition spd="med"/>
+</p:sld>
+</file>
+
+<file path=ppt/slides/slide12.xml><?xml version="1.0" encoding="utf-8"?>
+<p:sld xmlns:a="http://schemas.openxmlformats.org/drawingml/2006/main" xmlns:r="http://schemas.openxmlformats.org/officeDocument/2006/relationships" xmlns:p="http://schemas.openxmlformats.org/presentationml/2006/main">
+  <p:cSld>
+    <p:spTree>
+      <p:nvGrpSpPr>
+        <p:cNvPr id="1" name="">
+          <a:extLst>
+            <a:ext uri="{FF2B5EF4-FFF2-40B4-BE49-F238E27FC236}">
+              <a16:creationId xmlns:a16="http://schemas.microsoft.com/office/drawing/2014/main" id="{429F56C4-C640-E1CF-D4BC-0E1FDD76F49C}"/>
+            </a:ext>
+          </a:extLst>
+        </p:cNvPr>
+        <p:cNvGrpSpPr/>
+        <p:nvPr/>
+      </p:nvGrpSpPr>
+      <p:grpSpPr>
+        <a:xfrm>
+          <a:off x="0" y="0"/>
+          <a:ext cx="0" cy="0"/>
+          <a:chOff x="0" y="0"/>
+          <a:chExt cx="0" cy="0"/>
+        </a:xfrm>
+      </p:grpSpPr>
+      <p:sp>
+        <p:nvSpPr>
+          <p:cNvPr id="2" name="CuadroTexto 1">
+            <a:extLst>
+              <a:ext uri="{FF2B5EF4-FFF2-40B4-BE49-F238E27FC236}">
+                <a16:creationId xmlns:a16="http://schemas.microsoft.com/office/drawing/2014/main" id="{51721F05-1F00-6C08-9CCE-577994F6DAB6}"/>
+              </a:ext>
+            </a:extLst>
+          </p:cNvPr>
+          <p:cNvSpPr txBox="1"/>
+          <p:nvPr/>
+        </p:nvSpPr>
+        <p:spPr>
+          <a:xfrm>
+            <a:off x="2755900" y="4936961"/>
+            <a:ext cx="18872200" cy="3842077"/>
+          </a:xfrm>
+          <a:prstGeom prst="rect">
+            <a:avLst/>
+          </a:prstGeom>
+          <a:noFill/>
+          <a:ln w="12700" cap="flat">
+            <a:noFill/>
+            <a:miter lim="400000"/>
+          </a:ln>
+          <a:effectLst/>
+          <a:sp3d/>
+        </p:spPr>
+        <p:style>
+          <a:lnRef idx="0">
+            <a:scrgbClr r="0" g="0" b="0"/>
+          </a:lnRef>
+          <a:fillRef idx="0">
+            <a:scrgbClr r="0" g="0" b="0"/>
+          </a:fillRef>
+          <a:effectRef idx="0">
+            <a:scrgbClr r="0" g="0" b="0"/>
+          </a:effectRef>
+          <a:fontRef idx="none"/>
+        </p:style>
+        <p:txBody>
+          <a:bodyPr rot="0" spcFirstLastPara="1" vertOverflow="overflow" horzOverflow="overflow" vert="horz" wrap="square" lIns="50800" tIns="50800" rIns="50800" bIns="50800" numCol="1" spcCol="38100" rtlCol="0" anchor="ctr">
+            <a:spAutoFit/>
+          </a:bodyPr>
+          <a:lstStyle/>
+          <a:p>
+            <a:pPr marL="0" marR="0" indent="0" algn="ctr" defTabSz="2438338" rtl="0" fontAlgn="auto" latinLnBrk="0" hangingPunct="0">
+              <a:lnSpc>
+                <a:spcPct val="100000"/>
+              </a:lnSpc>
+              <a:spcBef>
+                <a:spcPts val="0"/>
+              </a:spcBef>
+              <a:spcAft>
+                <a:spcPts val="0"/>
+              </a:spcAft>
+              <a:buClrTx/>
+              <a:buSzTx/>
+              <a:buFontTx/>
+              <a:buNone/>
+              <a:tabLst/>
+            </a:pPr>
+            <a:r>
+              <a:rPr kumimoji="0" lang="es-ES" sz="24300" b="0" i="0" u="none" strike="noStrike" cap="none" spc="0" normalizeH="0" baseline="0" dirty="0" err="1">
+                <a:ln>
+                  <a:noFill/>
+                </a:ln>
+                <a:solidFill>
+                  <a:schemeClr val="bg1"/>
+                </a:solidFill>
+                <a:effectLst/>
+                <a:uFillTx/>
+                <a:latin typeface="Script MT Bold" panose="03040602040607080904" pitchFamily="66" charset="0"/>
+                <a:ea typeface="ADLaM Display" panose="02010000000000000000" pitchFamily="2" charset="0"/>
+                <a:cs typeface="ADLaM Display" panose="02010000000000000000" pitchFamily="2" charset="0"/>
+                <a:sym typeface="Helvetica Neue"/>
+              </a:rPr>
+              <a:t>End</a:t>
+            </a:r>
+            <a:r>
+              <a:rPr kumimoji="0" lang="es-ES" sz="24300" b="0" i="0" u="none" strike="noStrike" cap="none" spc="0" normalizeH="0" baseline="0" dirty="0">
+                <a:ln>
+                  <a:noFill/>
+                </a:ln>
+                <a:solidFill>
+                  <a:schemeClr val="bg1"/>
+                </a:solidFill>
+                <a:effectLst/>
+                <a:uFillTx/>
+                <a:latin typeface="Script MT Bold" panose="03040602040607080904" pitchFamily="66" charset="0"/>
+                <a:ea typeface="ADLaM Display" panose="02010000000000000000" pitchFamily="2" charset="0"/>
+                <a:cs typeface="ADLaM Display" panose="02010000000000000000" pitchFamily="2" charset="0"/>
+                <a:sym typeface="Helvetica Neue"/>
+              </a:rPr>
+              <a:t> </a:t>
+            </a:r>
+            <a:r>
+              <a:rPr kumimoji="0" lang="es-ES" sz="24300" b="0" i="0" u="none" strike="noStrike" cap="none" spc="0" normalizeH="0" baseline="0" dirty="0" err="1">
+                <a:ln>
+                  <a:noFill/>
+                </a:ln>
+                <a:solidFill>
+                  <a:schemeClr val="bg1"/>
+                </a:solidFill>
+                <a:effectLst/>
+                <a:uFillTx/>
+                <a:latin typeface="Script MT Bold" panose="03040602040607080904" pitchFamily="66" charset="0"/>
+                <a:ea typeface="ADLaM Display" panose="02010000000000000000" pitchFamily="2" charset="0"/>
+                <a:cs typeface="ADLaM Display" panose="02010000000000000000" pitchFamily="2" charset="0"/>
+                <a:sym typeface="Helvetica Neue"/>
+              </a:rPr>
+              <a:t>the</a:t>
+            </a:r>
+            <a:r>
+              <a:rPr kumimoji="0" lang="es-ES" sz="24300" b="0" i="0" u="none" strike="noStrike" cap="none" spc="0" normalizeH="0" baseline="0" dirty="0">
+                <a:ln>
+                  <a:noFill/>
+                </a:ln>
+                <a:solidFill>
+                  <a:schemeClr val="bg1"/>
+                </a:solidFill>
+                <a:effectLst/>
+                <a:uFillTx/>
+                <a:latin typeface="Script MT Bold" panose="03040602040607080904" pitchFamily="66" charset="0"/>
+                <a:ea typeface="ADLaM Display" panose="02010000000000000000" pitchFamily="2" charset="0"/>
+                <a:cs typeface="ADLaM Display" panose="02010000000000000000" pitchFamily="2" charset="0"/>
+                <a:sym typeface="Helvetica Neue"/>
+              </a:rPr>
+              <a:t> </a:t>
+            </a:r>
+            <a:r>
+              <a:rPr kumimoji="0" lang="es-ES" sz="24300" b="0" i="0" u="none" strike="noStrike" cap="none" spc="0" normalizeH="0" baseline="0" dirty="0" err="1">
+                <a:ln>
+                  <a:noFill/>
+                </a:ln>
+                <a:solidFill>
+                  <a:schemeClr val="bg1"/>
+                </a:solidFill>
+                <a:effectLst/>
+                <a:uFillTx/>
+                <a:latin typeface="Script MT Bold" panose="03040602040607080904" pitchFamily="66" charset="0"/>
+                <a:ea typeface="ADLaM Display" panose="02010000000000000000" pitchFamily="2" charset="0"/>
+                <a:cs typeface="ADLaM Display" panose="02010000000000000000" pitchFamily="2" charset="0"/>
+                <a:sym typeface="Helvetica Neue"/>
+              </a:rPr>
+              <a:t>day</a:t>
+            </a:r>
+            <a:r>
+              <a:rPr kumimoji="0" lang="es-ES" sz="24300" b="0" i="0" u="none" strike="noStrike" cap="none" spc="0" normalizeH="0" baseline="0" dirty="0">
+                <a:ln>
+                  <a:noFill/>
+                </a:ln>
+                <a:solidFill>
+                  <a:schemeClr val="bg1"/>
+                </a:solidFill>
+                <a:effectLst/>
+                <a:uFillTx/>
+                <a:latin typeface="Script MT Bold" panose="03040602040607080904" pitchFamily="66" charset="0"/>
+                <a:ea typeface="ADLaM Display" panose="02010000000000000000" pitchFamily="2" charset="0"/>
+                <a:cs typeface="ADLaM Display" panose="02010000000000000000" pitchFamily="2" charset="0"/>
+                <a:sym typeface="Helvetica Neue"/>
+              </a:rPr>
+              <a:t> 2</a:t>
+            </a:r>
+          </a:p>
+        </p:txBody>
+      </p:sp>
+    </p:spTree>
+    <p:extLst>
+      <p:ext uri="{BB962C8B-B14F-4D97-AF65-F5344CB8AC3E}">
+        <p14:creationId xmlns:p14="http://schemas.microsoft.com/office/powerpoint/2010/main" val="31621155"/>
+      </p:ext>
+    </p:extLst>
+  </p:cSld>
+  <p:clrMapOvr>
+    <a:masterClrMapping/>
+  </p:clrMapOvr>
+  <p:transition spd="med"/>
+</p:sld>
+</file>
+
+<file path=ppt/slides/slide13.xml><?xml version="1.0" encoding="utf-8"?>
+<p:sld xmlns:a="http://schemas.openxmlformats.org/drawingml/2006/main" xmlns:r="http://schemas.openxmlformats.org/officeDocument/2006/relationships" xmlns:p="http://schemas.openxmlformats.org/presentationml/2006/main">
+  <p:cSld>
+    <p:spTree>
+      <p:nvGrpSpPr>
+        <p:cNvPr id="1" name="">
+          <a:extLst>
+            <a:ext uri="{FF2B5EF4-FFF2-40B4-BE49-F238E27FC236}">
+              <a16:creationId xmlns:a16="http://schemas.microsoft.com/office/drawing/2014/main" id="{BCCE0B4B-F14C-7235-96E0-FCA7FF90D05F}"/>
+            </a:ext>
+          </a:extLst>
+        </p:cNvPr>
+        <p:cNvGrpSpPr/>
+        <p:nvPr/>
+      </p:nvGrpSpPr>
+      <p:grpSpPr>
+        <a:xfrm>
+          <a:off x="0" y="0"/>
+          <a:ext cx="0" cy="0"/>
+          <a:chOff x="0" y="0"/>
+          <a:chExt cx="0" cy="0"/>
+        </a:xfrm>
+      </p:grpSpPr>
+      <p:sp>
+        <p:nvSpPr>
+          <p:cNvPr id="26" name="CuadroTexto 25">
+            <a:extLst>
+              <a:ext uri="{FF2B5EF4-FFF2-40B4-BE49-F238E27FC236}">
+                <a16:creationId xmlns:a16="http://schemas.microsoft.com/office/drawing/2014/main" id="{BB3C0C01-9DE6-AD7C-1CC2-4B56F087073B}"/>
+              </a:ext>
+            </a:extLst>
+          </p:cNvPr>
+          <p:cNvSpPr txBox="1"/>
+          <p:nvPr/>
+        </p:nvSpPr>
+        <p:spPr>
+          <a:xfrm>
+            <a:off x="1417814" y="3879559"/>
+            <a:ext cx="1905444" cy="1719852"/>
+          </a:xfrm>
+          <a:prstGeom prst="rect">
+            <a:avLst/>
+          </a:prstGeom>
+        </p:spPr>
+        <p:txBody>
+          <a:bodyPr vert="horz" wrap="square" lIns="91440" tIns="45720" rIns="91440" bIns="45720" rtlCol="0">
+            <a:noAutofit/>
+          </a:bodyPr>
+          <a:lstStyle/>
+          <a:p>
+            <a:r>
+              <a:rPr lang="es-ES" sz="8800" b="1" dirty="0">
+                <a:solidFill>
+                  <a:srgbClr val="3479BB"/>
+                </a:solidFill>
+                <a:latin typeface="Montserrat" pitchFamily="2" charset="77"/>
+              </a:rPr>
+              <a:t>1. </a:t>
+            </a:r>
+          </a:p>
+        </p:txBody>
+      </p:sp>
+      <p:sp>
+        <p:nvSpPr>
+          <p:cNvPr id="46" name="CuadroTexto 45">
+            <a:extLst>
+              <a:ext uri="{FF2B5EF4-FFF2-40B4-BE49-F238E27FC236}">
+                <a16:creationId xmlns:a16="http://schemas.microsoft.com/office/drawing/2014/main" id="{A6BEA3A7-88C6-BEF1-F51D-FDDA3F045117}"/>
+              </a:ext>
+            </a:extLst>
+          </p:cNvPr>
+          <p:cNvSpPr txBox="1"/>
+          <p:nvPr/>
+        </p:nvSpPr>
+        <p:spPr>
+          <a:xfrm>
+            <a:off x="2783840" y="7256664"/>
+            <a:ext cx="20706080" cy="1719852"/>
+          </a:xfrm>
+          <a:prstGeom prst="rect">
+            <a:avLst/>
+          </a:prstGeom>
+        </p:spPr>
+        <p:txBody>
+          <a:bodyPr vert="horz" wrap="square" lIns="91440" tIns="45720" rIns="91440" bIns="45720" rtlCol="0">
+            <a:noAutofit/>
+          </a:bodyPr>
+          <a:lstStyle/>
+          <a:p>
+            <a:pPr algn="r"/>
+            <a:r>
+              <a:rPr lang="es-ES" sz="11500" b="1" dirty="0">
+                <a:solidFill>
+                  <a:srgbClr val="F2F2F2"/>
+                </a:solidFill>
+                <a:latin typeface="Montserrat" pitchFamily="2" charset="77"/>
+              </a:rPr>
+              <a:t>9. Deep </a:t>
+            </a:r>
+            <a:r>
+              <a:rPr lang="es-ES" sz="11500" b="1" dirty="0" err="1">
+                <a:solidFill>
+                  <a:srgbClr val="F2F2F2"/>
+                </a:solidFill>
+                <a:latin typeface="Montserrat" pitchFamily="2" charset="77"/>
+              </a:rPr>
+              <a:t>Learning</a:t>
+            </a:r>
+            <a:r>
+              <a:rPr lang="es-ES" sz="11500" b="1" dirty="0">
+                <a:solidFill>
+                  <a:srgbClr val="F2F2F2"/>
+                </a:solidFill>
+                <a:latin typeface="Montserrat" pitchFamily="2" charset="77"/>
+              </a:rPr>
+              <a:t>:</a:t>
+            </a:r>
+          </a:p>
+          <a:p>
+            <a:pPr algn="r"/>
+            <a:r>
+              <a:rPr lang="es-ES" sz="11500" b="1" dirty="0" err="1">
+                <a:solidFill>
+                  <a:srgbClr val="F2F2F2"/>
+                </a:solidFill>
+                <a:latin typeface="Montserrat" pitchFamily="2" charset="77"/>
+              </a:rPr>
+              <a:t>Convolutional</a:t>
+            </a:r>
+            <a:r>
+              <a:rPr lang="es-ES" sz="11500" b="1" dirty="0">
+                <a:solidFill>
+                  <a:srgbClr val="F2F2F2"/>
+                </a:solidFill>
+                <a:latin typeface="Montserrat" pitchFamily="2" charset="77"/>
+              </a:rPr>
+              <a:t> Neuronal Network (CNN)</a:t>
+            </a:r>
+          </a:p>
+        </p:txBody>
+      </p:sp>
+    </p:spTree>
+    <p:extLst>
+      <p:ext uri="{BB962C8B-B14F-4D97-AF65-F5344CB8AC3E}">
+        <p14:creationId xmlns:p14="http://schemas.microsoft.com/office/powerpoint/2010/main" val="2715285498"/>
+      </p:ext>
+    </p:extLst>
+  </p:cSld>
+  <p:clrMapOvr>
+    <a:masterClrMapping/>
+  </p:clrMapOvr>
+  <p:transition spd="med"/>
+</p:sld>
+</file>
+
+<file path=ppt/slides/slide14.xml><?xml version="1.0" encoding="utf-8"?>
+<p:sld xmlns:a="http://schemas.openxmlformats.org/drawingml/2006/main" xmlns:r="http://schemas.openxmlformats.org/officeDocument/2006/relationships" xmlns:p="http://schemas.openxmlformats.org/presentationml/2006/main">
+  <p:cSld>
+    <p:spTree>
+      <p:nvGrpSpPr>
+        <p:cNvPr id="1" name="">
+          <a:extLst>
+            <a:ext uri="{FF2B5EF4-FFF2-40B4-BE49-F238E27FC236}">
+              <a16:creationId xmlns:a16="http://schemas.microsoft.com/office/drawing/2014/main" id="{469524BC-9FBB-381A-90D3-B50A9B598955}"/>
+            </a:ext>
+          </a:extLst>
+        </p:cNvPr>
+        <p:cNvGrpSpPr/>
+        <p:nvPr/>
+      </p:nvGrpSpPr>
+      <p:grpSpPr>
+        <a:xfrm>
+          <a:off x="0" y="0"/>
+          <a:ext cx="0" cy="0"/>
+          <a:chOff x="0" y="0"/>
+          <a:chExt cx="0" cy="0"/>
+        </a:xfrm>
+      </p:grpSpPr>
+      <p:sp>
+        <p:nvSpPr>
+          <p:cNvPr id="26" name="CuadroTexto 25">
+            <a:extLst>
+              <a:ext uri="{FF2B5EF4-FFF2-40B4-BE49-F238E27FC236}">
+                <a16:creationId xmlns:a16="http://schemas.microsoft.com/office/drawing/2014/main" id="{6815A6B6-6D8E-7F89-C40B-D3FB3D2949F4}"/>
+              </a:ext>
+            </a:extLst>
+          </p:cNvPr>
+          <p:cNvSpPr txBox="1"/>
+          <p:nvPr/>
+        </p:nvSpPr>
+        <p:spPr>
+          <a:xfrm>
+            <a:off x="1417814" y="3879559"/>
+            <a:ext cx="1905444" cy="1719852"/>
+          </a:xfrm>
+          <a:prstGeom prst="rect">
+            <a:avLst/>
+          </a:prstGeom>
+        </p:spPr>
+        <p:txBody>
+          <a:bodyPr vert="horz" wrap="square" lIns="91440" tIns="45720" rIns="91440" bIns="45720" rtlCol="0">
+            <a:noAutofit/>
+          </a:bodyPr>
+          <a:lstStyle/>
+          <a:p>
+            <a:r>
+              <a:rPr lang="es-ES" sz="8800" b="1" dirty="0">
+                <a:solidFill>
+                  <a:srgbClr val="3479BB"/>
+                </a:solidFill>
+                <a:latin typeface="Montserrat" pitchFamily="2" charset="77"/>
+              </a:rPr>
+              <a:t>1. </a:t>
+            </a:r>
+          </a:p>
+        </p:txBody>
+      </p:sp>
+      <p:sp>
+        <p:nvSpPr>
+          <p:cNvPr id="46" name="CuadroTexto 45">
+            <a:extLst>
+              <a:ext uri="{FF2B5EF4-FFF2-40B4-BE49-F238E27FC236}">
+                <a16:creationId xmlns:a16="http://schemas.microsoft.com/office/drawing/2014/main" id="{BE7448C7-94B8-2D5E-AF97-73E754DA0880}"/>
+              </a:ext>
+            </a:extLst>
+          </p:cNvPr>
+          <p:cNvSpPr txBox="1"/>
+          <p:nvPr/>
+        </p:nvSpPr>
+        <p:spPr>
+          <a:xfrm>
+            <a:off x="2783840" y="7256664"/>
+            <a:ext cx="20706080" cy="1719852"/>
+          </a:xfrm>
+          <a:prstGeom prst="rect">
+            <a:avLst/>
+          </a:prstGeom>
+        </p:spPr>
+        <p:txBody>
+          <a:bodyPr vert="horz" wrap="square" lIns="91440" tIns="45720" rIns="91440" bIns="45720" rtlCol="0">
+            <a:noAutofit/>
+          </a:bodyPr>
+          <a:lstStyle/>
+          <a:p>
+            <a:pPr algn="r"/>
+            <a:r>
+              <a:rPr lang="es-ES" sz="11500" b="1" dirty="0">
+                <a:solidFill>
+                  <a:srgbClr val="F2F2F2"/>
+                </a:solidFill>
+                <a:latin typeface="Montserrat" pitchFamily="2" charset="77"/>
+              </a:rPr>
+              <a:t>10. Deep </a:t>
+            </a:r>
+            <a:r>
+              <a:rPr lang="es-ES" sz="11500" b="1" dirty="0" err="1">
+                <a:solidFill>
+                  <a:srgbClr val="F2F2F2"/>
+                </a:solidFill>
+                <a:latin typeface="Montserrat" pitchFamily="2" charset="77"/>
+              </a:rPr>
+              <a:t>Learning</a:t>
+            </a:r>
+            <a:r>
+              <a:rPr lang="es-ES" sz="11500" b="1" dirty="0">
+                <a:solidFill>
+                  <a:srgbClr val="F2F2F2"/>
+                </a:solidFill>
+                <a:latin typeface="Montserrat" pitchFamily="2" charset="77"/>
+              </a:rPr>
+              <a:t>:</a:t>
+            </a:r>
+          </a:p>
+          <a:p>
+            <a:pPr algn="r"/>
+            <a:r>
+              <a:rPr lang="es-ES" sz="11500" b="1" dirty="0">
+                <a:solidFill>
+                  <a:srgbClr val="F2F2F2"/>
+                </a:solidFill>
+                <a:latin typeface="Montserrat" pitchFamily="2" charset="77"/>
+              </a:rPr>
+              <a:t>Transfer </a:t>
+            </a:r>
+            <a:r>
+              <a:rPr lang="es-ES" sz="11500" b="1" dirty="0" err="1">
+                <a:solidFill>
+                  <a:srgbClr val="F2F2F2"/>
+                </a:solidFill>
+                <a:latin typeface="Montserrat" pitchFamily="2" charset="77"/>
+              </a:rPr>
+              <a:t>Learning</a:t>
+            </a:r>
+            <a:endParaRPr lang="es-ES" sz="11500" b="1" dirty="0">
+              <a:solidFill>
+                <a:srgbClr val="F2F2F2"/>
+              </a:solidFill>
+              <a:latin typeface="Montserrat" pitchFamily="2" charset="77"/>
+            </a:endParaRPr>
+          </a:p>
+        </p:txBody>
+      </p:sp>
+    </p:spTree>
+    <p:extLst>
+      <p:ext uri="{BB962C8B-B14F-4D97-AF65-F5344CB8AC3E}">
+        <p14:creationId xmlns:p14="http://schemas.microsoft.com/office/powerpoint/2010/main" val="3916363036"/>
+      </p:ext>
+    </p:extLst>
+  </p:cSld>
+  <p:clrMapOvr>
+    <a:masterClrMapping/>
+  </p:clrMapOvr>
+  <p:transition spd="med"/>
+</p:sld>
+</file>
+
+<file path=ppt/slides/slide15.xml><?xml version="1.0" encoding="utf-8"?>
+<p:sld xmlns:a="http://schemas.openxmlformats.org/drawingml/2006/main" xmlns:r="http://schemas.openxmlformats.org/officeDocument/2006/relationships" xmlns:p="http://schemas.openxmlformats.org/presentationml/2006/main">
+  <p:cSld>
+    <p:spTree>
+      <p:nvGrpSpPr>
+        <p:cNvPr id="1" name="">
+          <a:extLst>
+            <a:ext uri="{FF2B5EF4-FFF2-40B4-BE49-F238E27FC236}">
+              <a16:creationId xmlns:a16="http://schemas.microsoft.com/office/drawing/2014/main" id="{60C0F020-FB85-B129-97F3-6AA7C1225E65}"/>
+            </a:ext>
+          </a:extLst>
+        </p:cNvPr>
+        <p:cNvGrpSpPr/>
+        <p:nvPr/>
+      </p:nvGrpSpPr>
+      <p:grpSpPr>
+        <a:xfrm>
+          <a:off x="0" y="0"/>
+          <a:ext cx="0" cy="0"/>
+          <a:chOff x="0" y="0"/>
+          <a:chExt cx="0" cy="0"/>
+        </a:xfrm>
+      </p:grpSpPr>
+      <p:sp>
+        <p:nvSpPr>
+          <p:cNvPr id="26" name="CuadroTexto 25">
+            <a:extLst>
+              <a:ext uri="{FF2B5EF4-FFF2-40B4-BE49-F238E27FC236}">
+                <a16:creationId xmlns:a16="http://schemas.microsoft.com/office/drawing/2014/main" id="{4DF99C7D-D79C-D356-E6B7-4A96F0642984}"/>
+              </a:ext>
+            </a:extLst>
+          </p:cNvPr>
+          <p:cNvSpPr txBox="1"/>
+          <p:nvPr/>
+        </p:nvSpPr>
+        <p:spPr>
+          <a:xfrm>
+            <a:off x="1417814" y="3879559"/>
+            <a:ext cx="1905444" cy="1719852"/>
+          </a:xfrm>
+          <a:prstGeom prst="rect">
+            <a:avLst/>
+          </a:prstGeom>
+        </p:spPr>
+        <p:txBody>
+          <a:bodyPr vert="horz" wrap="square" lIns="91440" tIns="45720" rIns="91440" bIns="45720" rtlCol="0">
+            <a:noAutofit/>
+          </a:bodyPr>
+          <a:lstStyle/>
+          <a:p>
+            <a:r>
+              <a:rPr lang="es-ES" sz="8800" b="1" dirty="0">
+                <a:solidFill>
+                  <a:srgbClr val="3479BB"/>
+                </a:solidFill>
+                <a:latin typeface="Montserrat" pitchFamily="2" charset="77"/>
+              </a:rPr>
+              <a:t>1. </a:t>
+            </a:r>
+          </a:p>
+        </p:txBody>
+      </p:sp>
+      <p:sp>
+        <p:nvSpPr>
+          <p:cNvPr id="46" name="CuadroTexto 45">
+            <a:extLst>
+              <a:ext uri="{FF2B5EF4-FFF2-40B4-BE49-F238E27FC236}">
+                <a16:creationId xmlns:a16="http://schemas.microsoft.com/office/drawing/2014/main" id="{5BC70C81-0A86-5CBB-9E40-A5AC9EEE79E2}"/>
+              </a:ext>
+            </a:extLst>
+          </p:cNvPr>
+          <p:cNvSpPr txBox="1"/>
+          <p:nvPr/>
+        </p:nvSpPr>
+        <p:spPr>
+          <a:xfrm>
+            <a:off x="2783840" y="7256664"/>
+            <a:ext cx="20706080" cy="1719852"/>
+          </a:xfrm>
+          <a:prstGeom prst="rect">
+            <a:avLst/>
+          </a:prstGeom>
+        </p:spPr>
+        <p:txBody>
+          <a:bodyPr vert="horz" wrap="square" lIns="91440" tIns="45720" rIns="91440" bIns="45720" rtlCol="0">
+            <a:noAutofit/>
+          </a:bodyPr>
+          <a:lstStyle/>
+          <a:p>
+            <a:pPr algn="r"/>
+            <a:r>
+              <a:rPr lang="es-ES" sz="11500" b="1" dirty="0">
+                <a:solidFill>
+                  <a:srgbClr val="F2F2F2"/>
+                </a:solidFill>
+                <a:latin typeface="Montserrat" pitchFamily="2" charset="77"/>
+              </a:rPr>
+              <a:t>11. Casos de usos: </a:t>
+            </a:r>
+          </a:p>
+          <a:p>
+            <a:pPr algn="r"/>
+            <a:r>
+              <a:rPr lang="es-ES" sz="11500" b="1" dirty="0" err="1">
+                <a:solidFill>
+                  <a:srgbClr val="F2F2F2"/>
+                </a:solidFill>
+                <a:latin typeface="Montserrat" pitchFamily="2" charset="77"/>
+              </a:rPr>
+              <a:t>End</a:t>
+            </a:r>
+            <a:r>
+              <a:rPr lang="es-ES" sz="11500" b="1" dirty="0">
+                <a:solidFill>
+                  <a:srgbClr val="F2F2F2"/>
+                </a:solidFill>
+                <a:latin typeface="Montserrat" pitchFamily="2" charset="77"/>
+              </a:rPr>
+              <a:t> – </a:t>
+            </a:r>
+            <a:r>
+              <a:rPr lang="es-ES" sz="11500" b="1" dirty="0" err="1">
+                <a:solidFill>
+                  <a:srgbClr val="F2F2F2"/>
+                </a:solidFill>
+                <a:latin typeface="Montserrat" pitchFamily="2" charset="77"/>
+              </a:rPr>
+              <a:t>to</a:t>
+            </a:r>
+            <a:r>
+              <a:rPr lang="es-ES" sz="11500" b="1" dirty="0">
+                <a:solidFill>
+                  <a:srgbClr val="F2F2F2"/>
+                </a:solidFill>
+                <a:latin typeface="Montserrat" pitchFamily="2" charset="77"/>
+              </a:rPr>
+              <a:t> - </a:t>
+            </a:r>
+            <a:r>
+              <a:rPr lang="es-ES" sz="11500" b="1" dirty="0" err="1">
+                <a:solidFill>
+                  <a:srgbClr val="F2F2F2"/>
+                </a:solidFill>
+                <a:latin typeface="Montserrat" pitchFamily="2" charset="77"/>
+              </a:rPr>
+              <a:t>end</a:t>
+            </a:r>
+            <a:endParaRPr lang="es-ES" sz="11500" b="1" dirty="0">
+              <a:solidFill>
+                <a:srgbClr val="F2F2F2"/>
+              </a:solidFill>
+              <a:latin typeface="Montserrat" pitchFamily="2" charset="77"/>
+            </a:endParaRPr>
+          </a:p>
+        </p:txBody>
+      </p:sp>
+    </p:spTree>
+    <p:extLst>
+      <p:ext uri="{BB962C8B-B14F-4D97-AF65-F5344CB8AC3E}">
+        <p14:creationId xmlns:p14="http://schemas.microsoft.com/office/powerpoint/2010/main" val="2492934483"/>
+      </p:ext>
+    </p:extLst>
+  </p:cSld>
+  <p:clrMapOvr>
+    <a:masterClrMapping/>
+  </p:clrMapOvr>
+  <p:transition spd="med"/>
+</p:sld>
+</file>
+
+<file path=ppt/slides/slide16.xml><?xml version="1.0" encoding="utf-8"?>
+<p:sld xmlns:a="http://schemas.openxmlformats.org/drawingml/2006/main" xmlns:r="http://schemas.openxmlformats.org/officeDocument/2006/relationships" xmlns:p="http://schemas.openxmlformats.org/presentationml/2006/main">
+  <p:cSld>
+    <p:spTree>
+      <p:nvGrpSpPr>
+        <p:cNvPr id="1" name=""/>
+        <p:cNvGrpSpPr/>
+        <p:nvPr/>
+      </p:nvGrpSpPr>
+      <p:grpSpPr>
+        <a:xfrm>
+          <a:off x="0" y="0"/>
+          <a:ext cx="0" cy="0"/>
+          <a:chOff x="0" y="0"/>
+          <a:chExt cx="0" cy="0"/>
+        </a:xfrm>
+      </p:grpSpPr>
+      <p:sp>
+        <p:nvSpPr>
+          <p:cNvPr id="357" name="vicenc.fernandez@upc.edu"/>
+          <p:cNvSpPr txBox="1">
+            <a:spLocks noGrp="1"/>
+          </p:cNvSpPr>
+          <p:nvPr>
+            <p:ph type="title"/>
+          </p:nvPr>
+        </p:nvSpPr>
+        <p:spPr>
+          <a:prstGeom prst="rect">
+            <a:avLst/>
+          </a:prstGeom>
+        </p:spPr>
+        <p:txBody>
+          <a:bodyPr/>
+          <a:lstStyle>
+            <a:lvl1pPr>
+              <a:defRPr i="1"/>
+            </a:lvl1pPr>
+          </a:lstStyle>
+          <a:p>
+            <a:r>
+              <a:rPr lang="es-ES" dirty="0" err="1"/>
+              <a:t>sergi.ramirez</a:t>
+            </a:r>
+            <a:r>
+              <a:rPr dirty="0"/>
+              <a:t>@upc.edu</a:t>
+            </a:r>
+          </a:p>
+        </p:txBody>
+      </p:sp>
+    </p:spTree>
+  </p:cSld>
+  <p:clrMapOvr>
+    <a:masterClrMapping/>
+  </p:clrMapOvr>
+  <p:transition spd="med"/>
+</p:sld>
+</file>
+
+<file path=ppt/slides/slide17.xml><?xml version="1.0" encoding="utf-8"?>
+<p:sld xmlns:a="http://schemas.openxmlformats.org/drawingml/2006/main" xmlns:r="http://schemas.openxmlformats.org/officeDocument/2006/relationships" xmlns:p="http://schemas.openxmlformats.org/presentationml/2006/main" show="0">
+  <p:cSld>
+    <p:spTree>
+      <p:nvGrpSpPr>
+        <p:cNvPr id="1" name=""/>
+        <p:cNvGrpSpPr/>
+        <p:nvPr/>
+      </p:nvGrpSpPr>
+      <p:grpSpPr>
+        <a:xfrm>
+          <a:off x="0" y="0"/>
+          <a:ext cx="0" cy="0"/>
+          <a:chOff x="0" y="0"/>
+          <a:chExt cx="0" cy="0"/>
+        </a:xfrm>
+      </p:grpSpPr>
+      <p:sp>
+        <p:nvSpPr>
+          <p:cNvPr id="2" name="CuadroTexto 1">
+            <a:extLst>
+              <a:ext uri="{FF2B5EF4-FFF2-40B4-BE49-F238E27FC236}">
+                <a16:creationId xmlns:a16="http://schemas.microsoft.com/office/drawing/2014/main" id="{48FBE165-ABD4-81D8-CC0C-05CDB3372B74}"/>
+              </a:ext>
+            </a:extLst>
+          </p:cNvPr>
+          <p:cNvSpPr txBox="1"/>
+          <p:nvPr/>
+        </p:nvSpPr>
+        <p:spPr>
+          <a:xfrm>
+            <a:off x="2755900" y="4936961"/>
+            <a:ext cx="18872200" cy="3842077"/>
+          </a:xfrm>
+          <a:prstGeom prst="rect">
+            <a:avLst/>
+          </a:prstGeom>
+          <a:noFill/>
+          <a:ln w="12700" cap="flat">
+            <a:noFill/>
+            <a:miter lim="400000"/>
+          </a:ln>
+          <a:effectLst/>
+          <a:sp3d/>
+        </p:spPr>
+        <p:style>
+          <a:lnRef idx="0">
+            <a:scrgbClr r="0" g="0" b="0"/>
+          </a:lnRef>
+          <a:fillRef idx="0">
+            <a:scrgbClr r="0" g="0" b="0"/>
+          </a:fillRef>
+          <a:effectRef idx="0">
+            <a:scrgbClr r="0" g="0" b="0"/>
+          </a:effectRef>
+          <a:fontRef idx="none"/>
+        </p:style>
+        <p:txBody>
+          <a:bodyPr rot="0" spcFirstLastPara="1" vertOverflow="overflow" horzOverflow="overflow" vert="horz" wrap="square" lIns="50800" tIns="50800" rIns="50800" bIns="50800" numCol="1" spcCol="38100" rtlCol="0" anchor="ctr">
+            <a:spAutoFit/>
+          </a:bodyPr>
+          <a:lstStyle/>
+          <a:p>
+            <a:pPr marL="0" marR="0" indent="0" algn="ctr" defTabSz="2438338" rtl="0" fontAlgn="auto" latinLnBrk="0" hangingPunct="0">
+              <a:lnSpc>
+                <a:spcPct val="100000"/>
+              </a:lnSpc>
+              <a:spcBef>
+                <a:spcPts val="0"/>
+              </a:spcBef>
+              <a:spcAft>
+                <a:spcPts val="0"/>
+              </a:spcAft>
+              <a:buClrTx/>
+              <a:buSzTx/>
+              <a:buFontTx/>
+              <a:buNone/>
+              <a:tabLst/>
+            </a:pPr>
+            <a:r>
+              <a:rPr kumimoji="0" lang="es-ES" sz="24300" b="0" i="0" u="none" strike="noStrike" cap="none" spc="0" normalizeH="0" baseline="0" dirty="0">
+                <a:ln>
+                  <a:noFill/>
+                </a:ln>
+                <a:solidFill>
+                  <a:schemeClr val="bg1"/>
+                </a:solidFill>
+                <a:effectLst/>
+                <a:uFillTx/>
+                <a:latin typeface="ADLaM Display" panose="02010000000000000000" pitchFamily="2" charset="77"/>
+                <a:ea typeface="ADLaM Display" panose="02010000000000000000" pitchFamily="2" charset="77"/>
+                <a:cs typeface="ADLaM Display" panose="02010000000000000000" pitchFamily="2" charset="77"/>
+                <a:sym typeface="Helvetica Neue"/>
+              </a:rPr>
+              <a:t>FINAL DIA 1</a:t>
+            </a:r>
+          </a:p>
+        </p:txBody>
+      </p:sp>
+      <p:sp>
+        <p:nvSpPr>
+          <p:cNvPr id="3" name="Rectángulo 2">
+            <a:extLst>
+              <a:ext uri="{FF2B5EF4-FFF2-40B4-BE49-F238E27FC236}">
+                <a16:creationId xmlns:a16="http://schemas.microsoft.com/office/drawing/2014/main" id="{658913AC-9300-E97A-7EBB-BCA9550587E8}"/>
+              </a:ext>
+            </a:extLst>
+          </p:cNvPr>
+          <p:cNvSpPr/>
+          <p:nvPr/>
+        </p:nvSpPr>
+        <p:spPr>
+          <a:xfrm>
+            <a:off x="3592054" y="5190168"/>
+            <a:ext cx="6487160" cy="4042132"/>
+          </a:xfrm>
+          <a:prstGeom prst="rect">
+            <a:avLst/>
+          </a:prstGeom>
+          <a:solidFill>
+            <a:srgbClr val="3479BB">
+              <a:alpha val="62000"/>
+            </a:srgbClr>
+          </a:solidFill>
+          <a:ln w="12700" cap="flat">
+            <a:noFill/>
+            <a:miter lim="400000"/>
+          </a:ln>
+          <a:effectLst/>
+          <a:sp3d/>
+        </p:spPr>
+        <p:style>
+          <a:lnRef idx="0">
+            <a:scrgbClr r="0" g="0" b="0"/>
+          </a:lnRef>
+          <a:fillRef idx="0">
+            <a:scrgbClr r="0" g="0" b="0"/>
+          </a:fillRef>
+          <a:effectRef idx="0">
+            <a:scrgbClr r="0" g="0" b="0"/>
+          </a:effectRef>
+          <a:fontRef idx="none"/>
+        </p:style>
+        <p:txBody>
+          <a:bodyPr rot="0" spcFirstLastPara="1" vertOverflow="overflow" horzOverflow="overflow" vert="horz" wrap="square" lIns="50800" tIns="50800" rIns="50800" bIns="50800" numCol="1" spcCol="38100" rtlCol="0" anchor="ctr">
+            <a:spAutoFit/>
+          </a:bodyPr>
+          <a:lstStyle/>
+          <a:p>
+            <a:pPr marL="0" marR="0" indent="0" algn="ctr" defTabSz="825500" rtl="0" fontAlgn="auto" latinLnBrk="0" hangingPunct="0">
+              <a:lnSpc>
+                <a:spcPct val="100000"/>
+              </a:lnSpc>
+              <a:spcBef>
+                <a:spcPts val="0"/>
+              </a:spcBef>
+              <a:spcAft>
+                <a:spcPts val="0"/>
+              </a:spcAft>
+              <a:buClrTx/>
+              <a:buSzTx/>
+              <a:buFontTx/>
+              <a:buNone/>
+              <a:tabLst/>
+            </a:pPr>
+            <a:endParaRPr kumimoji="0" lang="es-ES" sz="3200" b="0" i="0" u="none" strike="noStrike" cap="none" spc="0" normalizeH="0" baseline="0" dirty="0">
+              <a:ln>
+                <a:noFill/>
+              </a:ln>
+              <a:solidFill>
+                <a:srgbClr val="FFFFFF"/>
+              </a:solidFill>
+              <a:effectLst/>
+              <a:uFillTx/>
+              <a:latin typeface="Helvetica Neue Medium"/>
+              <a:ea typeface="Helvetica Neue Medium"/>
+              <a:cs typeface="Helvetica Neue Medium"/>
+              <a:sym typeface="Helvetica Neue Medium"/>
+            </a:endParaRPr>
+          </a:p>
+          <a:p>
+            <a:pPr marL="0" marR="0" indent="0" algn="ctr" defTabSz="825500" rtl="0" fontAlgn="auto" latinLnBrk="0" hangingPunct="0">
+              <a:lnSpc>
+                <a:spcPct val="100000"/>
+              </a:lnSpc>
+              <a:spcBef>
+                <a:spcPts val="0"/>
+              </a:spcBef>
+              <a:spcAft>
+                <a:spcPts val="0"/>
+              </a:spcAft>
+              <a:buClrTx/>
+              <a:buSzTx/>
+              <a:buFontTx/>
+              <a:buNone/>
+              <a:tabLst/>
+            </a:pPr>
+            <a:endParaRPr lang="es-ES" sz="3200" dirty="0">
+              <a:solidFill>
+                <a:srgbClr val="FFFFFF"/>
+              </a:solidFill>
+              <a:latin typeface="Helvetica Neue Medium"/>
+              <a:ea typeface="Helvetica Neue Medium"/>
+              <a:cs typeface="Helvetica Neue Medium"/>
+              <a:sym typeface="Helvetica Neue Medium"/>
+            </a:endParaRPr>
+          </a:p>
+          <a:p>
+            <a:pPr marL="0" marR="0" indent="0" algn="ctr" defTabSz="825500" rtl="0" fontAlgn="auto" latinLnBrk="0" hangingPunct="0">
+              <a:lnSpc>
+                <a:spcPct val="100000"/>
+              </a:lnSpc>
+              <a:spcBef>
+                <a:spcPts val="0"/>
+              </a:spcBef>
+              <a:spcAft>
+                <a:spcPts val="0"/>
+              </a:spcAft>
+              <a:buClrTx/>
+              <a:buSzTx/>
+              <a:buFontTx/>
+              <a:buNone/>
+              <a:tabLst/>
+            </a:pPr>
+            <a:endParaRPr kumimoji="0" lang="es-ES" sz="3200" b="0" i="0" u="none" strike="noStrike" cap="none" spc="0" normalizeH="0" baseline="0" dirty="0">
+              <a:ln>
+                <a:noFill/>
+              </a:ln>
+              <a:solidFill>
+                <a:srgbClr val="FFFFFF"/>
+              </a:solidFill>
+              <a:effectLst/>
+              <a:uFillTx/>
+              <a:latin typeface="Helvetica Neue Medium"/>
+              <a:ea typeface="Helvetica Neue Medium"/>
+              <a:cs typeface="Helvetica Neue Medium"/>
+              <a:sym typeface="Helvetica Neue Medium"/>
+            </a:endParaRPr>
+          </a:p>
+          <a:p>
+            <a:pPr marL="0" marR="0" indent="0" algn="ctr" defTabSz="825500" rtl="0" fontAlgn="auto" latinLnBrk="0" hangingPunct="0">
+              <a:lnSpc>
+                <a:spcPct val="100000"/>
+              </a:lnSpc>
+              <a:spcBef>
+                <a:spcPts val="0"/>
+              </a:spcBef>
+              <a:spcAft>
+                <a:spcPts val="0"/>
+              </a:spcAft>
+              <a:buClrTx/>
+              <a:buSzTx/>
+              <a:buFontTx/>
+              <a:buNone/>
+              <a:tabLst/>
+            </a:pPr>
+            <a:endParaRPr lang="es-ES" sz="3200" dirty="0">
+              <a:solidFill>
+                <a:srgbClr val="FFFFFF"/>
+              </a:solidFill>
+              <a:latin typeface="Helvetica Neue Medium"/>
+              <a:ea typeface="Helvetica Neue Medium"/>
+              <a:cs typeface="Helvetica Neue Medium"/>
+              <a:sym typeface="Helvetica Neue Medium"/>
+            </a:endParaRPr>
+          </a:p>
+          <a:p>
+            <a:pPr marL="0" marR="0" indent="0" algn="ctr" defTabSz="825500" rtl="0" fontAlgn="auto" latinLnBrk="0" hangingPunct="0">
+              <a:lnSpc>
+                <a:spcPct val="100000"/>
+              </a:lnSpc>
+              <a:spcBef>
+                <a:spcPts val="0"/>
+              </a:spcBef>
+              <a:spcAft>
+                <a:spcPts val="0"/>
+              </a:spcAft>
+              <a:buClrTx/>
+              <a:buSzTx/>
+              <a:buFontTx/>
+              <a:buNone/>
+              <a:tabLst/>
+            </a:pPr>
+            <a:endParaRPr kumimoji="0" lang="es-ES" sz="3200" b="0" i="0" u="none" strike="noStrike" cap="none" spc="0" normalizeH="0" baseline="0" dirty="0">
+              <a:ln>
+                <a:noFill/>
+              </a:ln>
+              <a:solidFill>
+                <a:srgbClr val="FFFFFF"/>
+              </a:solidFill>
+              <a:effectLst/>
+              <a:uFillTx/>
+              <a:latin typeface="Helvetica Neue Medium"/>
+              <a:ea typeface="Helvetica Neue Medium"/>
+              <a:cs typeface="Helvetica Neue Medium"/>
+              <a:sym typeface="Helvetica Neue Medium"/>
+            </a:endParaRPr>
+          </a:p>
+          <a:p>
+            <a:pPr marL="0" marR="0" indent="0" algn="ctr" defTabSz="825500" rtl="0" fontAlgn="auto" latinLnBrk="0" hangingPunct="0">
+              <a:lnSpc>
+                <a:spcPct val="100000"/>
+              </a:lnSpc>
+              <a:spcBef>
+                <a:spcPts val="0"/>
+              </a:spcBef>
+              <a:spcAft>
+                <a:spcPts val="0"/>
+              </a:spcAft>
+              <a:buClrTx/>
+              <a:buSzTx/>
+              <a:buFontTx/>
+              <a:buNone/>
+              <a:tabLst/>
+            </a:pPr>
+            <a:endParaRPr lang="es-ES" sz="3200" dirty="0">
+              <a:solidFill>
+                <a:srgbClr val="FFFFFF"/>
+              </a:solidFill>
+              <a:latin typeface="Helvetica Neue Medium"/>
+              <a:ea typeface="Helvetica Neue Medium"/>
+              <a:cs typeface="Helvetica Neue Medium"/>
+              <a:sym typeface="Helvetica Neue Medium"/>
+            </a:endParaRPr>
+          </a:p>
+          <a:p>
+            <a:pPr marL="0" marR="0" indent="0" algn="ctr" defTabSz="825500" rtl="0" fontAlgn="auto" latinLnBrk="0" hangingPunct="0">
+              <a:lnSpc>
+                <a:spcPct val="100000"/>
+              </a:lnSpc>
+              <a:spcBef>
+                <a:spcPts val="0"/>
+              </a:spcBef>
+              <a:spcAft>
+                <a:spcPts val="0"/>
+              </a:spcAft>
+              <a:buClrTx/>
+              <a:buSzTx/>
+              <a:buFontTx/>
+              <a:buNone/>
+              <a:tabLst/>
+            </a:pPr>
+            <a:endParaRPr kumimoji="0" lang="es-ES" sz="3200" b="0" i="0" u="none" strike="noStrike" cap="none" spc="0" normalizeH="0" baseline="0" dirty="0">
+              <a:ln>
+                <a:noFill/>
+              </a:ln>
+              <a:solidFill>
+                <a:srgbClr val="FFFFFF"/>
+              </a:solidFill>
+              <a:effectLst/>
+              <a:uFillTx/>
+              <a:latin typeface="Helvetica Neue Medium"/>
+              <a:ea typeface="Helvetica Neue Medium"/>
+              <a:cs typeface="Helvetica Neue Medium"/>
+              <a:sym typeface="Helvetica Neue Medium"/>
+            </a:endParaRPr>
+          </a:p>
+          <a:p>
+            <a:pPr marL="0" marR="0" indent="0" algn="ctr" defTabSz="825500" rtl="0" fontAlgn="auto" latinLnBrk="0" hangingPunct="0">
+              <a:lnSpc>
+                <a:spcPct val="100000"/>
+              </a:lnSpc>
+              <a:spcBef>
+                <a:spcPts val="0"/>
+              </a:spcBef>
+              <a:spcAft>
+                <a:spcPts val="0"/>
+              </a:spcAft>
+              <a:buClrTx/>
+              <a:buSzTx/>
+              <a:buFontTx/>
+              <a:buNone/>
+              <a:tabLst/>
+            </a:pPr>
+            <a:endParaRPr kumimoji="0" lang="es-ES" sz="3200" b="0" i="0" u="none" strike="noStrike" cap="none" spc="0" normalizeH="0" baseline="0" dirty="0">
+              <a:ln>
+                <a:noFill/>
+              </a:ln>
+              <a:solidFill>
+                <a:srgbClr val="FFFFFF"/>
+              </a:solidFill>
+              <a:effectLst/>
+              <a:uFillTx/>
+              <a:latin typeface="Helvetica Neue Medium"/>
+              <a:ea typeface="Helvetica Neue Medium"/>
+              <a:cs typeface="Helvetica Neue Medium"/>
+              <a:sym typeface="Helvetica Neue Medium"/>
+            </a:endParaRPr>
+          </a:p>
+        </p:txBody>
+      </p:sp>
+    </p:spTree>
+    <p:extLst>
+      <p:ext uri="{BB962C8B-B14F-4D97-AF65-F5344CB8AC3E}">
+        <p14:creationId xmlns:p14="http://schemas.microsoft.com/office/powerpoint/2010/main" val="1365634657"/>
+      </p:ext>
+    </p:extLst>
   </p:cSld>
   <p:clrMapOvr>
     <a:masterClrMapping/>
@@ -7467,7 +8894,7 @@
         </p:blipFill>
         <p:spPr bwMode="auto">
           <a:xfrm>
-            <a:off x="4655864" y="146304"/>
+            <a:off x="2766104" y="664368"/>
             <a:ext cx="13536081" cy="12387263"/>
           </a:xfrm>
           <a:prstGeom prst="rect">
@@ -7504,7 +8931,13 @@
   <p:cSld>
     <p:spTree>
       <p:nvGrpSpPr>
-        <p:cNvPr id="1" name=""/>
+        <p:cNvPr id="1" name="">
+          <a:extLst>
+            <a:ext uri="{FF2B5EF4-FFF2-40B4-BE49-F238E27FC236}">
+              <a16:creationId xmlns:a16="http://schemas.microsoft.com/office/drawing/2014/main" id="{D40D903E-0335-BE61-BD6B-FB3F8CAC6003}"/>
+            </a:ext>
+          </a:extLst>
+        </p:cNvPr>
         <p:cNvGrpSpPr/>
         <p:nvPr/>
       </p:nvGrpSpPr>
@@ -7518,490 +8951,89 @@
       </p:grpSpPr>
       <p:sp>
         <p:nvSpPr>
-          <p:cNvPr id="353" name="Agenda"/>
-          <p:cNvSpPr txBox="1">
-            <a:spLocks noGrp="1"/>
-          </p:cNvSpPr>
-          <p:nvPr>
-            <p:ph type="title"/>
-          </p:nvPr>
+          <p:cNvPr id="26" name="CuadroTexto 25">
+            <a:extLst>
+              <a:ext uri="{FF2B5EF4-FFF2-40B4-BE49-F238E27FC236}">
+                <a16:creationId xmlns:a16="http://schemas.microsoft.com/office/drawing/2014/main" id="{DD84C0C8-4C70-8D58-A544-87BAB76D6E5B}"/>
+              </a:ext>
+            </a:extLst>
+          </p:cNvPr>
+          <p:cNvSpPr txBox="1"/>
+          <p:nvPr/>
         </p:nvSpPr>
         <p:spPr>
+          <a:xfrm>
+            <a:off x="1417814" y="3879559"/>
+            <a:ext cx="1905444" cy="1719852"/>
+          </a:xfrm>
           <a:prstGeom prst="rect">
             <a:avLst/>
           </a:prstGeom>
         </p:spPr>
         <p:txBody>
-          <a:bodyPr/>
+          <a:bodyPr vert="horz" wrap="square" lIns="91440" tIns="45720" rIns="91440" bIns="45720" rtlCol="0">
+            <a:noAutofit/>
+          </a:bodyPr>
           <a:lstStyle/>
           <a:p>
             <a:r>
-              <a:t>Agenda</a:t>
+              <a:rPr lang="es-ES" sz="8800" b="1" dirty="0">
+                <a:solidFill>
+                  <a:srgbClr val="3479BB"/>
+                </a:solidFill>
+                <a:latin typeface="Montserrat" pitchFamily="2" charset="77"/>
+              </a:rPr>
+              <a:t>1. </a:t>
             </a:r>
           </a:p>
         </p:txBody>
       </p:sp>
       <p:sp>
         <p:nvSpPr>
-          <p:cNvPr id="354" name="Número de diapositiva"/>
-          <p:cNvSpPr txBox="1">
-            <a:spLocks noGrp="1"/>
-          </p:cNvSpPr>
-          <p:nvPr>
-            <p:ph type="sldNum" sz="quarter" idx="2"/>
-          </p:nvPr>
-        </p:nvSpPr>
-        <p:spPr>
-          <a:xfrm>
-            <a:off x="12065050" y="13080999"/>
-            <a:ext cx="241403" cy="374600"/>
-          </a:xfrm>
-          <a:prstGeom prst="rect">
-            <a:avLst/>
-          </a:prstGeom>
-          <a:extLst>
-            <a:ext uri="{C572A759-6A51-4108-AA02-DFA0A04FC94B}">
-              <ma14:wrappingTextBoxFlag xmlns:ma14="http://schemas.microsoft.com/office/mac/drawingml/2011/main" xmlns:a14="http://schemas.microsoft.com/office/drawing/2010/main" xmlns:m="http://schemas.openxmlformats.org/officeDocument/2006/math" xmlns="" val="1"/>
-            </a:ext>
-          </a:extLst>
-        </p:spPr>
-        <p:txBody>
-          <a:bodyPr/>
-          <a:lstStyle/>
-          <a:p>
-            <a:fld id="{86CB4B4D-7CA3-9044-876B-883B54F8677D}" type="slidenum">
-              <a:rPr/>
-              <a:t>3</a:t>
-            </a:fld>
-            <a:endParaRPr/>
-          </a:p>
-        </p:txBody>
-      </p:sp>
-      <p:sp>
-        <p:nvSpPr>
-          <p:cNvPr id="8" name="Rectángulo 7">
+          <p:cNvPr id="46" name="CuadroTexto 45">
             <a:extLst>
               <a:ext uri="{FF2B5EF4-FFF2-40B4-BE49-F238E27FC236}">
-                <a16:creationId xmlns:a16="http://schemas.microsoft.com/office/drawing/2014/main" id="{8976EAF4-3406-1482-8D1B-D7F2D544019C}"/>
+                <a16:creationId xmlns:a16="http://schemas.microsoft.com/office/drawing/2014/main" id="{5E42FA19-8765-EF4D-0310-705A62EE2BBD}"/>
               </a:ext>
             </a:extLst>
           </p:cNvPr>
-          <p:cNvSpPr/>
+          <p:cNvSpPr txBox="1"/>
           <p:nvPr/>
         </p:nvSpPr>
         <p:spPr>
           <a:xfrm>
-            <a:off x="2184704" y="4998970"/>
-            <a:ext cx="5774163" cy="2872581"/>
+            <a:off x="8351520" y="8006459"/>
+            <a:ext cx="15016480" cy="1719852"/>
           </a:xfrm>
           <a:prstGeom prst="rect">
             <a:avLst/>
           </a:prstGeom>
-          <a:ln/>
-        </p:spPr>
-        <p:style>
-          <a:lnRef idx="2">
-            <a:schemeClr val="dk1"/>
-          </a:lnRef>
-          <a:fillRef idx="1">
-            <a:schemeClr val="lt1"/>
-          </a:fillRef>
-          <a:effectRef idx="0">
-            <a:schemeClr val="dk1"/>
-          </a:effectRef>
-          <a:fontRef idx="minor">
-            <a:schemeClr val="dk1"/>
-          </a:fontRef>
-        </p:style>
+        </p:spPr>
         <p:txBody>
-          <a:bodyPr rot="0" spcFirstLastPara="1" vertOverflow="overflow" horzOverflow="overflow" vert="horz" wrap="square" lIns="50800" tIns="50800" rIns="50800" bIns="50800" numCol="1" spcCol="38100" rtlCol="0" anchor="b">
-            <a:spAutoFit/>
+          <a:bodyPr vert="horz" wrap="square" lIns="91440" tIns="45720" rIns="91440" bIns="45720" rtlCol="0">
+            <a:noAutofit/>
           </a:bodyPr>
           <a:lstStyle/>
           <a:p>
-            <a:pPr marR="0" algn="l" defTabSz="825500" rtl="0" fontAlgn="auto" latinLnBrk="0" hangingPunct="0">
-              <a:lnSpc>
-                <a:spcPct val="100000"/>
-              </a:lnSpc>
-              <a:spcBef>
-                <a:spcPts val="0"/>
-              </a:spcBef>
-              <a:spcAft>
-                <a:spcPts val="0"/>
-              </a:spcAft>
-              <a:buClrTx/>
-              <a:buSzTx/>
-              <a:tabLst/>
-            </a:pPr>
-            <a:endParaRPr kumimoji="0" lang="es-ES" sz="6000" b="1" i="0" u="none" strike="noStrike" cap="none" spc="0" normalizeH="0" baseline="0" dirty="0">
-              <a:ln>
-                <a:noFill/>
-              </a:ln>
-              <a:solidFill>
-                <a:srgbClr val="3479BB"/>
-              </a:solidFill>
-              <a:effectLst/>
-              <a:uFillTx/>
-              <a:latin typeface="Helvetica Neue Medium"/>
-              <a:ea typeface="Helvetica Neue Medium"/>
-              <a:cs typeface="Helvetica Neue Medium"/>
-              <a:sym typeface="Helvetica Neue Medium"/>
-            </a:endParaRPr>
-          </a:p>
-          <a:p>
-            <a:pPr marR="0" algn="l" defTabSz="825500" rtl="0" fontAlgn="auto" latinLnBrk="0" hangingPunct="0">
-              <a:lnSpc>
-                <a:spcPct val="100000"/>
-              </a:lnSpc>
-              <a:spcBef>
-                <a:spcPts val="0"/>
-              </a:spcBef>
-              <a:spcAft>
-                <a:spcPts val="0"/>
-              </a:spcAft>
-              <a:buClrTx/>
-              <a:buSzTx/>
-              <a:tabLst/>
-            </a:pPr>
-            <a:r>
-              <a:rPr kumimoji="0" lang="es-ES" sz="6000" b="1" i="0" u="none" strike="noStrike" cap="none" spc="0" normalizeH="0" baseline="0" dirty="0">
-                <a:ln>
-                  <a:noFill/>
-                </a:ln>
-                <a:solidFill>
-                  <a:srgbClr val="3479BB"/>
-                </a:solidFill>
-                <a:effectLst/>
-                <a:uFillTx/>
-                <a:latin typeface="Helvetica Neue Medium"/>
-                <a:ea typeface="Helvetica Neue Medium"/>
-                <a:cs typeface="Helvetica Neue Medium"/>
-                <a:sym typeface="Helvetica Neue Medium"/>
+            <a:pPr algn="r"/>
+            <a:r>
+              <a:rPr lang="es-ES" sz="11500" b="1" dirty="0">
+                <a:solidFill>
+                  <a:srgbClr val="F2F2F2"/>
+                </a:solidFill>
+                <a:latin typeface="Montserrat" pitchFamily="2" charset="77"/>
               </a:rPr>
-              <a:t>01. MODELS SUPERVISATS</a:t>
-            </a:r>
-          </a:p>
-        </p:txBody>
-      </p:sp>
-      <p:sp>
-        <p:nvSpPr>
-          <p:cNvPr id="17" name="Rectángulo 16">
-            <a:extLst>
-              <a:ext uri="{FF2B5EF4-FFF2-40B4-BE49-F238E27FC236}">
-                <a16:creationId xmlns:a16="http://schemas.microsoft.com/office/drawing/2014/main" id="{12855C56-94F5-5B3E-93C8-4CD2662D6D85}"/>
-              </a:ext>
-            </a:extLst>
-          </p:cNvPr>
-          <p:cNvSpPr/>
-          <p:nvPr/>
-        </p:nvSpPr>
-        <p:spPr>
-          <a:xfrm>
-            <a:off x="8672548" y="4998971"/>
-            <a:ext cx="5774163" cy="2872581"/>
-          </a:xfrm>
-          <a:prstGeom prst="rect">
-            <a:avLst/>
-          </a:prstGeom>
-          <a:ln/>
-        </p:spPr>
-        <p:style>
-          <a:lnRef idx="2">
-            <a:schemeClr val="dk1"/>
-          </a:lnRef>
-          <a:fillRef idx="1">
-            <a:schemeClr val="lt1"/>
-          </a:fillRef>
-          <a:effectRef idx="0">
-            <a:schemeClr val="dk1"/>
-          </a:effectRef>
-          <a:fontRef idx="minor">
-            <a:schemeClr val="dk1"/>
-          </a:fontRef>
-        </p:style>
-        <p:txBody>
-          <a:bodyPr rot="0" spcFirstLastPara="1" vertOverflow="overflow" horzOverflow="overflow" vert="horz" wrap="square" lIns="50800" tIns="50800" rIns="50800" bIns="50800" numCol="1" spcCol="38100" rtlCol="0" anchor="b">
-            <a:spAutoFit/>
-          </a:bodyPr>
-          <a:lstStyle/>
-          <a:p>
-            <a:pPr marR="0" algn="l" defTabSz="825500" rtl="0" fontAlgn="auto" latinLnBrk="0" hangingPunct="0">
-              <a:lnSpc>
-                <a:spcPct val="100000"/>
-              </a:lnSpc>
-              <a:spcBef>
-                <a:spcPts val="0"/>
-              </a:spcBef>
-              <a:spcAft>
-                <a:spcPts val="0"/>
-              </a:spcAft>
-              <a:buClrTx/>
-              <a:buSzTx/>
-              <a:tabLst/>
-            </a:pPr>
-            <a:endParaRPr kumimoji="0" lang="es-ES" sz="6000" b="1" i="0" u="none" strike="noStrike" cap="none" spc="0" normalizeH="0" baseline="0" dirty="0">
-              <a:ln>
-                <a:noFill/>
-              </a:ln>
-              <a:solidFill>
-                <a:srgbClr val="3479BB"/>
-              </a:solidFill>
-              <a:effectLst/>
-              <a:uFillTx/>
-              <a:latin typeface="Helvetica Neue Medium"/>
-              <a:ea typeface="Helvetica Neue Medium"/>
-              <a:cs typeface="Helvetica Neue Medium"/>
-              <a:sym typeface="Helvetica Neue Medium"/>
-            </a:endParaRPr>
-          </a:p>
-          <a:p>
-            <a:pPr marR="0" algn="l" defTabSz="825500" rtl="0" fontAlgn="auto" latinLnBrk="0" hangingPunct="0">
-              <a:lnSpc>
-                <a:spcPct val="100000"/>
-              </a:lnSpc>
-              <a:spcBef>
-                <a:spcPts val="0"/>
-              </a:spcBef>
-              <a:spcAft>
-                <a:spcPts val="0"/>
-              </a:spcAft>
-              <a:buClrTx/>
-              <a:buSzTx/>
-              <a:tabLst/>
-            </a:pPr>
-            <a:r>
-              <a:rPr kumimoji="0" lang="es-ES" sz="6000" b="1" i="0" u="none" strike="noStrike" cap="none" spc="0" normalizeH="0" baseline="0" dirty="0">
-                <a:ln>
-                  <a:noFill/>
-                </a:ln>
-                <a:solidFill>
-                  <a:srgbClr val="3479BB"/>
-                </a:solidFill>
-                <a:effectLst/>
-                <a:uFillTx/>
-                <a:latin typeface="Helvetica Neue Medium"/>
-                <a:ea typeface="Helvetica Neue Medium"/>
-                <a:cs typeface="Helvetica Neue Medium"/>
-                <a:sym typeface="Helvetica Neue Medium"/>
-              </a:rPr>
-              <a:t>01. MODELS SUPERVISATS</a:t>
-            </a:r>
-          </a:p>
-        </p:txBody>
-      </p:sp>
-      <p:sp>
-        <p:nvSpPr>
-          <p:cNvPr id="18" name="Rectángulo 17">
-            <a:extLst>
-              <a:ext uri="{FF2B5EF4-FFF2-40B4-BE49-F238E27FC236}">
-                <a16:creationId xmlns:a16="http://schemas.microsoft.com/office/drawing/2014/main" id="{3E73D25C-A3AC-1C8A-B9E5-A577FDC18552}"/>
-              </a:ext>
-            </a:extLst>
-          </p:cNvPr>
-          <p:cNvSpPr/>
-          <p:nvPr/>
-        </p:nvSpPr>
-        <p:spPr>
-          <a:xfrm>
-            <a:off x="2184704" y="9143568"/>
-            <a:ext cx="5774163" cy="2872581"/>
-          </a:xfrm>
-          <a:prstGeom prst="rect">
-            <a:avLst/>
-          </a:prstGeom>
-          <a:ln/>
-        </p:spPr>
-        <p:style>
-          <a:lnRef idx="2">
-            <a:schemeClr val="dk1"/>
-          </a:lnRef>
-          <a:fillRef idx="1">
-            <a:schemeClr val="lt1"/>
-          </a:fillRef>
-          <a:effectRef idx="0">
-            <a:schemeClr val="dk1"/>
-          </a:effectRef>
-          <a:fontRef idx="minor">
-            <a:schemeClr val="dk1"/>
-          </a:fontRef>
-        </p:style>
-        <p:txBody>
-          <a:bodyPr rot="0" spcFirstLastPara="1" vertOverflow="overflow" horzOverflow="overflow" vert="horz" wrap="square" lIns="50800" tIns="50800" rIns="50800" bIns="50800" numCol="1" spcCol="38100" rtlCol="0" anchor="b">
-            <a:spAutoFit/>
-          </a:bodyPr>
-          <a:lstStyle/>
-          <a:p>
-            <a:pPr marR="0" algn="l" defTabSz="825500" rtl="0" fontAlgn="auto" latinLnBrk="0" hangingPunct="0">
-              <a:lnSpc>
-                <a:spcPct val="100000"/>
-              </a:lnSpc>
-              <a:spcBef>
-                <a:spcPts val="0"/>
-              </a:spcBef>
-              <a:spcAft>
-                <a:spcPts val="0"/>
-              </a:spcAft>
-              <a:buClrTx/>
-              <a:buSzTx/>
-              <a:tabLst/>
-            </a:pPr>
-            <a:endParaRPr kumimoji="0" lang="es-ES" sz="6000" b="1" i="0" u="none" strike="noStrike" cap="none" spc="0" normalizeH="0" baseline="0" dirty="0">
-              <a:ln>
-                <a:noFill/>
-              </a:ln>
-              <a:solidFill>
-                <a:srgbClr val="3479BB"/>
-              </a:solidFill>
-              <a:effectLst/>
-              <a:uFillTx/>
-              <a:latin typeface="Helvetica Neue Medium"/>
-              <a:ea typeface="Helvetica Neue Medium"/>
-              <a:cs typeface="Helvetica Neue Medium"/>
-              <a:sym typeface="Helvetica Neue Medium"/>
-            </a:endParaRPr>
-          </a:p>
-          <a:p>
-            <a:pPr marR="0" algn="l" defTabSz="825500" rtl="0" fontAlgn="auto" latinLnBrk="0" hangingPunct="0">
-              <a:lnSpc>
-                <a:spcPct val="100000"/>
-              </a:lnSpc>
-              <a:spcBef>
-                <a:spcPts val="0"/>
-              </a:spcBef>
-              <a:spcAft>
-                <a:spcPts val="0"/>
-              </a:spcAft>
-              <a:buClrTx/>
-              <a:buSzTx/>
-              <a:tabLst/>
-            </a:pPr>
-            <a:r>
-              <a:rPr kumimoji="0" lang="es-ES" sz="6000" b="1" i="0" u="none" strike="noStrike" cap="none" spc="0" normalizeH="0" baseline="0" dirty="0">
-                <a:ln>
-                  <a:noFill/>
-                </a:ln>
-                <a:solidFill>
-                  <a:srgbClr val="3479BB"/>
-                </a:solidFill>
-                <a:effectLst/>
-                <a:uFillTx/>
-                <a:latin typeface="Helvetica Neue Medium"/>
-                <a:ea typeface="Helvetica Neue Medium"/>
-                <a:cs typeface="Helvetica Neue Medium"/>
-                <a:sym typeface="Helvetica Neue Medium"/>
-              </a:rPr>
-              <a:t>01. MODELS SUPERVISATS</a:t>
-            </a:r>
-          </a:p>
-        </p:txBody>
-      </p:sp>
-      <p:sp>
-        <p:nvSpPr>
-          <p:cNvPr id="19" name="Rectángulo 18">
-            <a:extLst>
-              <a:ext uri="{FF2B5EF4-FFF2-40B4-BE49-F238E27FC236}">
-                <a16:creationId xmlns:a16="http://schemas.microsoft.com/office/drawing/2014/main" id="{CAA9BEC0-1425-9D7C-9AC1-FFE05DEDBEEE}"/>
-              </a:ext>
-            </a:extLst>
-          </p:cNvPr>
-          <p:cNvSpPr/>
-          <p:nvPr/>
-        </p:nvSpPr>
-        <p:spPr>
-          <a:xfrm>
-            <a:off x="8672548" y="9143568"/>
-            <a:ext cx="5774163" cy="2872581"/>
-          </a:xfrm>
-          <a:prstGeom prst="rect">
-            <a:avLst/>
-          </a:prstGeom>
-          <a:ln/>
-        </p:spPr>
-        <p:style>
-          <a:lnRef idx="2">
-            <a:schemeClr val="dk1"/>
-          </a:lnRef>
-          <a:fillRef idx="1">
-            <a:schemeClr val="lt1"/>
-          </a:fillRef>
-          <a:effectRef idx="0">
-            <a:schemeClr val="dk1"/>
-          </a:effectRef>
-          <a:fontRef idx="minor">
-            <a:schemeClr val="dk1"/>
-          </a:fontRef>
-        </p:style>
-        <p:txBody>
-          <a:bodyPr rot="0" spcFirstLastPara="1" vertOverflow="overflow" horzOverflow="overflow" vert="horz" wrap="square" lIns="50800" tIns="50800" rIns="50800" bIns="50800" numCol="1" spcCol="38100" rtlCol="0" anchor="b">
-            <a:spAutoFit/>
-          </a:bodyPr>
-          <a:lstStyle/>
-          <a:p>
-            <a:pPr marR="0" algn="l" defTabSz="825500" rtl="0" fontAlgn="auto" latinLnBrk="0" hangingPunct="0">
-              <a:lnSpc>
-                <a:spcPct val="100000"/>
-              </a:lnSpc>
-              <a:spcBef>
-                <a:spcPts val="0"/>
-              </a:spcBef>
-              <a:spcAft>
-                <a:spcPts val="0"/>
-              </a:spcAft>
-              <a:buClrTx/>
-              <a:buSzTx/>
-              <a:tabLst/>
-            </a:pPr>
-            <a:endParaRPr kumimoji="0" lang="es-ES" sz="6000" b="1" i="0" u="none" strike="noStrike" cap="none" spc="0" normalizeH="0" baseline="0" dirty="0">
-              <a:ln>
-                <a:noFill/>
-              </a:ln>
-              <a:solidFill>
-                <a:srgbClr val="3479BB"/>
-              </a:solidFill>
-              <a:effectLst/>
-              <a:uFillTx/>
-              <a:latin typeface="Helvetica Neue Medium"/>
-              <a:ea typeface="Helvetica Neue Medium"/>
-              <a:cs typeface="Helvetica Neue Medium"/>
-              <a:sym typeface="Helvetica Neue Medium"/>
-            </a:endParaRPr>
-          </a:p>
-          <a:p>
-            <a:pPr marR="0" algn="l" defTabSz="825500" rtl="0" fontAlgn="auto" latinLnBrk="0" hangingPunct="0">
-              <a:lnSpc>
-                <a:spcPct val="100000"/>
-              </a:lnSpc>
-              <a:spcBef>
-                <a:spcPts val="0"/>
-              </a:spcBef>
-              <a:spcAft>
-                <a:spcPts val="0"/>
-              </a:spcAft>
-              <a:buClrTx/>
-              <a:buSzTx/>
-              <a:tabLst/>
-            </a:pPr>
-            <a:r>
-              <a:rPr kumimoji="0" lang="es-ES" sz="6000" b="1" i="0" u="none" strike="noStrike" cap="none" spc="0" normalizeH="0" baseline="0" dirty="0">
-                <a:ln>
-                  <a:noFill/>
-                </a:ln>
-                <a:solidFill>
-                  <a:srgbClr val="3479BB"/>
-                </a:solidFill>
-                <a:effectLst/>
-                <a:uFillTx/>
-                <a:latin typeface="Helvetica Neue Medium"/>
-                <a:ea typeface="Helvetica Neue Medium"/>
-                <a:cs typeface="Helvetica Neue Medium"/>
-                <a:sym typeface="Helvetica Neue Medium"/>
-              </a:rPr>
-              <a:t>01. MODELS SUPERVISATS</a:t>
+              <a:t>1.  Modelos supervisados</a:t>
             </a:r>
           </a:p>
         </p:txBody>
       </p:sp>
     </p:spTree>
+    <p:extLst>
+      <p:ext uri="{BB962C8B-B14F-4D97-AF65-F5344CB8AC3E}">
+        <p14:creationId xmlns:p14="http://schemas.microsoft.com/office/powerpoint/2010/main" val="892759005"/>
+      </p:ext>
+    </p:extLst>
   </p:cSld>
   <p:clrMapOvr>
     <a:masterClrMapping/>
@@ -8015,7 +9047,13 @@
   <p:cSld>
     <p:spTree>
       <p:nvGrpSpPr>
-        <p:cNvPr id="1" name=""/>
+        <p:cNvPr id="1" name="">
+          <a:extLst>
+            <a:ext uri="{FF2B5EF4-FFF2-40B4-BE49-F238E27FC236}">
+              <a16:creationId xmlns:a16="http://schemas.microsoft.com/office/drawing/2014/main" id="{63E5D213-98AD-484E-ED8B-4F787C9A6B94}"/>
+            </a:ext>
+          </a:extLst>
+        </p:cNvPr>
         <p:cNvGrpSpPr/>
         <p:nvPr/>
       </p:nvGrpSpPr>
@@ -8029,10 +9067,10 @@
       </p:grpSpPr>
       <p:sp>
         <p:nvSpPr>
-          <p:cNvPr id="2" name="CuadroTexto 1">
+          <p:cNvPr id="26" name="CuadroTexto 25">
             <a:extLst>
               <a:ext uri="{FF2B5EF4-FFF2-40B4-BE49-F238E27FC236}">
-                <a16:creationId xmlns:a16="http://schemas.microsoft.com/office/drawing/2014/main" id="{48FBE165-ABD4-81D8-CC0C-05CDB3372B74}"/>
+                <a16:creationId xmlns:a16="http://schemas.microsoft.com/office/drawing/2014/main" id="{5F4C3C3D-6360-816C-9538-FF26EEE56498}"/>
               </a:ext>
             </a:extLst>
           </p:cNvPr>
@@ -8041,70 +9079,67 @@
         </p:nvSpPr>
         <p:spPr>
           <a:xfrm>
-            <a:off x="2755900" y="4936961"/>
-            <a:ext cx="18872200" cy="3842077"/>
+            <a:off x="1417814" y="3879559"/>
+            <a:ext cx="1905444" cy="1719852"/>
           </a:xfrm>
           <a:prstGeom prst="rect">
             <a:avLst/>
           </a:prstGeom>
-          <a:noFill/>
-          <a:ln w="12700" cap="flat">
-            <a:noFill/>
-            <a:miter lim="400000"/>
-          </a:ln>
-          <a:effectLst/>
-          <a:sp3d/>
-        </p:spPr>
-        <p:style>
-          <a:lnRef idx="0">
-            <a:scrgbClr r="0" g="0" b="0"/>
-          </a:lnRef>
-          <a:fillRef idx="0">
-            <a:scrgbClr r="0" g="0" b="0"/>
-          </a:fillRef>
-          <a:effectRef idx="0">
-            <a:scrgbClr r="0" g="0" b="0"/>
-          </a:effectRef>
-          <a:fontRef idx="none"/>
-        </p:style>
+        </p:spPr>
         <p:txBody>
-          <a:bodyPr rot="0" spcFirstLastPara="1" vertOverflow="overflow" horzOverflow="overflow" vert="horz" wrap="square" lIns="50800" tIns="50800" rIns="50800" bIns="50800" numCol="1" spcCol="38100" rtlCol="0" anchor="ctr">
-            <a:spAutoFit/>
+          <a:bodyPr vert="horz" wrap="square" lIns="91440" tIns="45720" rIns="91440" bIns="45720" rtlCol="0">
+            <a:noAutofit/>
           </a:bodyPr>
           <a:lstStyle/>
           <a:p>
-            <a:pPr marL="0" marR="0" indent="0" algn="ctr" defTabSz="2438338" rtl="0" fontAlgn="auto" latinLnBrk="0" hangingPunct="0">
-              <a:lnSpc>
-                <a:spcPct val="100000"/>
-              </a:lnSpc>
-              <a:spcBef>
-                <a:spcPts val="0"/>
-              </a:spcBef>
-              <a:spcAft>
-                <a:spcPts val="0"/>
-              </a:spcAft>
-              <a:buClrTx/>
-              <a:buSzTx/>
-              <a:buFontTx/>
-              <a:buNone/>
-              <a:tabLst/>
-            </a:pPr>
-            <a:r>
-              <a:rPr kumimoji="0" lang="es-ES" sz="24300" b="0" i="0" u="none" strike="noStrike" cap="none" spc="0" normalizeH="0" baseline="0" dirty="0">
-                <a:ln>
-                  <a:noFill/>
-                </a:ln>
-                <a:solidFill>
-                  <a:schemeClr val="bg1"/>
-                </a:solidFill>
-                <a:effectLst/>
-                <a:uFillTx/>
-                <a:latin typeface="ADLaM Display" panose="02010000000000000000" pitchFamily="2" charset="77"/>
-                <a:ea typeface="ADLaM Display" panose="02010000000000000000" pitchFamily="2" charset="77"/>
-                <a:cs typeface="ADLaM Display" panose="02010000000000000000" pitchFamily="2" charset="77"/>
-                <a:sym typeface="Helvetica Neue"/>
+            <a:r>
+              <a:rPr lang="es-ES" sz="8800" b="1" dirty="0">
+                <a:solidFill>
+                  <a:srgbClr val="3479BB"/>
+                </a:solidFill>
+                <a:latin typeface="Montserrat" pitchFamily="2" charset="77"/>
               </a:rPr>
-              <a:t>FINAL DIA 1</a:t>
+              <a:t>1. </a:t>
+            </a:r>
+          </a:p>
+        </p:txBody>
+      </p:sp>
+      <p:sp>
+        <p:nvSpPr>
+          <p:cNvPr id="46" name="CuadroTexto 45">
+            <a:extLst>
+              <a:ext uri="{FF2B5EF4-FFF2-40B4-BE49-F238E27FC236}">
+                <a16:creationId xmlns:a16="http://schemas.microsoft.com/office/drawing/2014/main" id="{5ED8B24D-D0A3-6575-5619-1271E66A880F}"/>
+              </a:ext>
+            </a:extLst>
+          </p:cNvPr>
+          <p:cNvSpPr txBox="1"/>
+          <p:nvPr/>
+        </p:nvSpPr>
+        <p:spPr>
+          <a:xfrm>
+            <a:off x="8351520" y="8006459"/>
+            <a:ext cx="15016480" cy="1719852"/>
+          </a:xfrm>
+          <a:prstGeom prst="rect">
+            <a:avLst/>
+          </a:prstGeom>
+        </p:spPr>
+        <p:txBody>
+          <a:bodyPr vert="horz" wrap="square" lIns="91440" tIns="45720" rIns="91440" bIns="45720" rtlCol="0">
+            <a:noAutofit/>
+          </a:bodyPr>
+          <a:lstStyle/>
+          <a:p>
+            <a:pPr algn="r"/>
+            <a:r>
+              <a:rPr lang="es-ES" sz="11500" b="1" dirty="0">
+                <a:solidFill>
+                  <a:srgbClr val="F2F2F2"/>
+                </a:solidFill>
+                <a:latin typeface="Montserrat" pitchFamily="2" charset="77"/>
+              </a:rPr>
+              <a:t>2.  Modelos lineales generalizados </a:t>
             </a:r>
           </a:p>
         </p:txBody>
@@ -8112,7 +9147,7 @@
     </p:spTree>
     <p:extLst>
       <p:ext uri="{BB962C8B-B14F-4D97-AF65-F5344CB8AC3E}">
-        <p14:creationId xmlns:p14="http://schemas.microsoft.com/office/powerpoint/2010/main" val="1365634657"/>
+        <p14:creationId xmlns:p14="http://schemas.microsoft.com/office/powerpoint/2010/main" val="1268194915"/>
       </p:ext>
     </p:extLst>
   </p:cSld>
@@ -8131,7 +9166,298 @@
         <p:cNvPr id="1" name="">
           <a:extLst>
             <a:ext uri="{FF2B5EF4-FFF2-40B4-BE49-F238E27FC236}">
-              <a16:creationId xmlns:a16="http://schemas.microsoft.com/office/drawing/2014/main" id="{8C486EAA-7190-0E66-6E8A-AA3B7FC85244}"/>
+              <a16:creationId xmlns:a16="http://schemas.microsoft.com/office/drawing/2014/main" id="{68D38A64-BCF3-0738-8F00-F6254B3C1477}"/>
+            </a:ext>
+          </a:extLst>
+        </p:cNvPr>
+        <p:cNvGrpSpPr/>
+        <p:nvPr/>
+      </p:nvGrpSpPr>
+      <p:grpSpPr>
+        <a:xfrm>
+          <a:off x="0" y="0"/>
+          <a:ext cx="0" cy="0"/>
+          <a:chOff x="0" y="0"/>
+          <a:chExt cx="0" cy="0"/>
+        </a:xfrm>
+      </p:grpSpPr>
+      <p:sp>
+        <p:nvSpPr>
+          <p:cNvPr id="26" name="CuadroTexto 25">
+            <a:extLst>
+              <a:ext uri="{FF2B5EF4-FFF2-40B4-BE49-F238E27FC236}">
+                <a16:creationId xmlns:a16="http://schemas.microsoft.com/office/drawing/2014/main" id="{24B046AC-0743-2DB5-7246-3C15513B745C}"/>
+              </a:ext>
+            </a:extLst>
+          </p:cNvPr>
+          <p:cNvSpPr txBox="1"/>
+          <p:nvPr/>
+        </p:nvSpPr>
+        <p:spPr>
+          <a:xfrm>
+            <a:off x="1417814" y="3879559"/>
+            <a:ext cx="1905444" cy="1719852"/>
+          </a:xfrm>
+          <a:prstGeom prst="rect">
+            <a:avLst/>
+          </a:prstGeom>
+        </p:spPr>
+        <p:txBody>
+          <a:bodyPr vert="horz" wrap="square" lIns="91440" tIns="45720" rIns="91440" bIns="45720" rtlCol="0">
+            <a:noAutofit/>
+          </a:bodyPr>
+          <a:lstStyle/>
+          <a:p>
+            <a:r>
+              <a:rPr lang="es-ES" sz="8800" b="1" dirty="0">
+                <a:solidFill>
+                  <a:srgbClr val="3479BB"/>
+                </a:solidFill>
+                <a:latin typeface="Montserrat" pitchFamily="2" charset="77"/>
+              </a:rPr>
+              <a:t>1. </a:t>
+            </a:r>
+          </a:p>
+        </p:txBody>
+      </p:sp>
+      <p:sp>
+        <p:nvSpPr>
+          <p:cNvPr id="46" name="CuadroTexto 45">
+            <a:extLst>
+              <a:ext uri="{FF2B5EF4-FFF2-40B4-BE49-F238E27FC236}">
+                <a16:creationId xmlns:a16="http://schemas.microsoft.com/office/drawing/2014/main" id="{FF1198CA-E540-40B2-FA95-17A2FBD3DA45}"/>
+              </a:ext>
+            </a:extLst>
+          </p:cNvPr>
+          <p:cNvSpPr txBox="1"/>
+          <p:nvPr/>
+        </p:nvSpPr>
+        <p:spPr>
+          <a:xfrm>
+            <a:off x="8351520" y="8006459"/>
+            <a:ext cx="15016480" cy="1719852"/>
+          </a:xfrm>
+          <a:prstGeom prst="rect">
+            <a:avLst/>
+          </a:prstGeom>
+        </p:spPr>
+        <p:txBody>
+          <a:bodyPr vert="horz" wrap="square" lIns="91440" tIns="45720" rIns="91440" bIns="45720" rtlCol="0">
+            <a:noAutofit/>
+          </a:bodyPr>
+          <a:lstStyle/>
+          <a:p>
+            <a:pPr algn="r"/>
+            <a:r>
+              <a:rPr lang="es-ES" sz="11500" b="1" dirty="0">
+                <a:solidFill>
+                  <a:srgbClr val="F2F2F2"/>
+                </a:solidFill>
+                <a:latin typeface="Montserrat" pitchFamily="2" charset="77"/>
+              </a:rPr>
+              <a:t>3.  Árboles de decisión</a:t>
+            </a:r>
+          </a:p>
+        </p:txBody>
+      </p:sp>
+    </p:spTree>
+    <p:extLst>
+      <p:ext uri="{BB962C8B-B14F-4D97-AF65-F5344CB8AC3E}">
+        <p14:creationId xmlns:p14="http://schemas.microsoft.com/office/powerpoint/2010/main" val="3102087876"/>
+      </p:ext>
+    </p:extLst>
+  </p:cSld>
+  <p:clrMapOvr>
+    <a:masterClrMapping/>
+  </p:clrMapOvr>
+  <p:transition spd="med"/>
+</p:sld>
+</file>
+
+<file path=ppt/slides/slide6.xml><?xml version="1.0" encoding="utf-8"?>
+<p:sld xmlns:a="http://schemas.openxmlformats.org/drawingml/2006/main" xmlns:r="http://schemas.openxmlformats.org/officeDocument/2006/relationships" xmlns:p="http://schemas.openxmlformats.org/presentationml/2006/main">
+  <p:cSld>
+    <p:spTree>
+      <p:nvGrpSpPr>
+        <p:cNvPr id="1" name="">
+          <a:extLst>
+            <a:ext uri="{FF2B5EF4-FFF2-40B4-BE49-F238E27FC236}">
+              <a16:creationId xmlns:a16="http://schemas.microsoft.com/office/drawing/2014/main" id="{5CE27486-3B44-CCB1-5762-08157B22B3CF}"/>
+            </a:ext>
+          </a:extLst>
+        </p:cNvPr>
+        <p:cNvGrpSpPr/>
+        <p:nvPr/>
+      </p:nvGrpSpPr>
+      <p:grpSpPr>
+        <a:xfrm>
+          <a:off x="0" y="0"/>
+          <a:ext cx="0" cy="0"/>
+          <a:chOff x="0" y="0"/>
+          <a:chExt cx="0" cy="0"/>
+        </a:xfrm>
+      </p:grpSpPr>
+      <p:sp>
+        <p:nvSpPr>
+          <p:cNvPr id="26" name="CuadroTexto 25">
+            <a:extLst>
+              <a:ext uri="{FF2B5EF4-FFF2-40B4-BE49-F238E27FC236}">
+                <a16:creationId xmlns:a16="http://schemas.microsoft.com/office/drawing/2014/main" id="{F615E401-48D9-DF72-5EC1-B6990AA880B6}"/>
+              </a:ext>
+            </a:extLst>
+          </p:cNvPr>
+          <p:cNvSpPr txBox="1"/>
+          <p:nvPr/>
+        </p:nvSpPr>
+        <p:spPr>
+          <a:xfrm>
+            <a:off x="1417814" y="3879559"/>
+            <a:ext cx="1905444" cy="1719852"/>
+          </a:xfrm>
+          <a:prstGeom prst="rect">
+            <a:avLst/>
+          </a:prstGeom>
+        </p:spPr>
+        <p:txBody>
+          <a:bodyPr vert="horz" wrap="square" lIns="91440" tIns="45720" rIns="91440" bIns="45720" rtlCol="0">
+            <a:noAutofit/>
+          </a:bodyPr>
+          <a:lstStyle/>
+          <a:p>
+            <a:r>
+              <a:rPr lang="es-ES" sz="8800" b="1" dirty="0">
+                <a:solidFill>
+                  <a:srgbClr val="3479BB"/>
+                </a:solidFill>
+                <a:latin typeface="Montserrat" pitchFamily="2" charset="77"/>
+              </a:rPr>
+              <a:t>1. </a:t>
+            </a:r>
+          </a:p>
+        </p:txBody>
+      </p:sp>
+      <p:sp>
+        <p:nvSpPr>
+          <p:cNvPr id="46" name="CuadroTexto 45">
+            <a:extLst>
+              <a:ext uri="{FF2B5EF4-FFF2-40B4-BE49-F238E27FC236}">
+                <a16:creationId xmlns:a16="http://schemas.microsoft.com/office/drawing/2014/main" id="{D06AACBE-E58B-81E6-32DB-C4555014F09B}"/>
+              </a:ext>
+            </a:extLst>
+          </p:cNvPr>
+          <p:cNvSpPr txBox="1"/>
+          <p:nvPr/>
+        </p:nvSpPr>
+        <p:spPr>
+          <a:xfrm>
+            <a:off x="8351520" y="8006459"/>
+            <a:ext cx="15016480" cy="1719852"/>
+          </a:xfrm>
+          <a:prstGeom prst="rect">
+            <a:avLst/>
+          </a:prstGeom>
+        </p:spPr>
+        <p:txBody>
+          <a:bodyPr vert="horz" wrap="square" lIns="91440" tIns="45720" rIns="91440" bIns="45720" rtlCol="0">
+            <a:noAutofit/>
+          </a:bodyPr>
+          <a:lstStyle/>
+          <a:p>
+            <a:pPr marL="1371600" indent="-1371600" algn="r">
+              <a:buAutoNum type="arabicPeriod" startAt="4"/>
+            </a:pPr>
+            <a:r>
+              <a:rPr lang="es-ES" sz="11500" b="1" dirty="0">
+                <a:solidFill>
+                  <a:srgbClr val="F2F2F2"/>
+                </a:solidFill>
+                <a:latin typeface="Montserrat" pitchFamily="2" charset="77"/>
+              </a:rPr>
+              <a:t> </a:t>
+            </a:r>
+            <a:r>
+              <a:rPr lang="es-ES" sz="11500" b="1" dirty="0" err="1">
+                <a:solidFill>
+                  <a:srgbClr val="F2F2F2"/>
+                </a:solidFill>
+                <a:latin typeface="Montserrat" pitchFamily="2" charset="77"/>
+              </a:rPr>
+              <a:t>Bagging</a:t>
+            </a:r>
+            <a:r>
+              <a:rPr lang="es-ES" sz="11500" b="1" dirty="0">
+                <a:solidFill>
+                  <a:srgbClr val="F2F2F2"/>
+                </a:solidFill>
+                <a:latin typeface="Montserrat" pitchFamily="2" charset="77"/>
+              </a:rPr>
+              <a:t> </a:t>
+            </a:r>
+            <a:r>
+              <a:rPr lang="es-ES" sz="11500" b="1" dirty="0" err="1">
+                <a:solidFill>
+                  <a:srgbClr val="F2F2F2"/>
+                </a:solidFill>
+                <a:latin typeface="Montserrat" pitchFamily="2" charset="77"/>
+              </a:rPr>
+              <a:t>models</a:t>
+            </a:r>
+            <a:r>
+              <a:rPr lang="es-ES" sz="11500" b="1" dirty="0">
+                <a:solidFill>
+                  <a:srgbClr val="F2F2F2"/>
+                </a:solidFill>
+                <a:latin typeface="Montserrat" pitchFamily="2" charset="77"/>
+              </a:rPr>
+              <a:t>:  </a:t>
+            </a:r>
+          </a:p>
+          <a:p>
+            <a:pPr algn="r"/>
+            <a:r>
+              <a:rPr lang="es-ES" sz="11500" b="1" dirty="0" err="1">
+                <a:solidFill>
+                  <a:srgbClr val="F2F2F2"/>
+                </a:solidFill>
+                <a:latin typeface="Montserrat" pitchFamily="2" charset="77"/>
+              </a:rPr>
+              <a:t>Random</a:t>
+            </a:r>
+            <a:r>
+              <a:rPr lang="es-ES" sz="11500" b="1" dirty="0">
+                <a:solidFill>
+                  <a:srgbClr val="F2F2F2"/>
+                </a:solidFill>
+                <a:latin typeface="Montserrat" pitchFamily="2" charset="77"/>
+              </a:rPr>
+              <a:t> Forest</a:t>
+            </a:r>
+          </a:p>
+        </p:txBody>
+      </p:sp>
+    </p:spTree>
+    <p:extLst>
+      <p:ext uri="{BB962C8B-B14F-4D97-AF65-F5344CB8AC3E}">
+        <p14:creationId xmlns:p14="http://schemas.microsoft.com/office/powerpoint/2010/main" val="58496880"/>
+      </p:ext>
+    </p:extLst>
+  </p:cSld>
+  <p:clrMapOvr>
+    <a:masterClrMapping/>
+  </p:clrMapOvr>
+  <p:transition spd="med"/>
+</p:sld>
+</file>
+
+<file path=ppt/slides/slide7.xml><?xml version="1.0" encoding="utf-8"?>
+<p:sld xmlns:a="http://schemas.openxmlformats.org/drawingml/2006/main" xmlns:r="http://schemas.openxmlformats.org/officeDocument/2006/relationships" xmlns:p="http://schemas.openxmlformats.org/presentationml/2006/main">
+  <p:cSld>
+    <p:spTree>
+      <p:nvGrpSpPr>
+        <p:cNvPr id="1" name="">
+          <a:extLst>
+            <a:ext uri="{FF2B5EF4-FFF2-40B4-BE49-F238E27FC236}">
+              <a16:creationId xmlns:a16="http://schemas.microsoft.com/office/drawing/2014/main" id="{DA3813ED-47B1-C7C0-ECB0-809269841C8D}"/>
             </a:ext>
           </a:extLst>
         </p:cNvPr>
@@ -8151,7 +9477,7 @@
           <p:cNvPr id="2" name="CuadroTexto 1">
             <a:extLst>
               <a:ext uri="{FF2B5EF4-FFF2-40B4-BE49-F238E27FC236}">
-                <a16:creationId xmlns:a16="http://schemas.microsoft.com/office/drawing/2014/main" id="{5005F7B1-00EB-6E26-AF4F-4E47473C3636}"/>
+                <a16:creationId xmlns:a16="http://schemas.microsoft.com/office/drawing/2014/main" id="{51D1D47F-9072-9C7B-072B-22A521695B66}"/>
               </a:ext>
             </a:extLst>
           </p:cNvPr>
@@ -8209,6 +9535,23 @@
               <a:tabLst/>
             </a:pPr>
             <a:r>
+              <a:rPr kumimoji="0" lang="es-ES" sz="24300" b="0" i="0" u="none" strike="noStrike" cap="none" spc="0" normalizeH="0" baseline="0" dirty="0" err="1">
+                <a:ln>
+                  <a:noFill/>
+                </a:ln>
+                <a:solidFill>
+                  <a:schemeClr val="bg1"/>
+                </a:solidFill>
+                <a:effectLst/>
+                <a:uFillTx/>
+                <a:latin typeface="Script MT Bold" panose="03040602040607080904" pitchFamily="66" charset="0"/>
+                <a:ea typeface="ADLaM Display" panose="02010000000000000000" pitchFamily="2" charset="0"/>
+                <a:cs typeface="ADLaM Display" panose="02010000000000000000" pitchFamily="2" charset="0"/>
+                <a:sym typeface="Helvetica Neue"/>
+              </a:rPr>
+              <a:t>End</a:t>
+            </a:r>
+            <a:r>
               <a:rPr kumimoji="0" lang="es-ES" sz="24300" b="0" i="0" u="none" strike="noStrike" cap="none" spc="0" normalizeH="0" baseline="0" dirty="0">
                 <a:ln>
                   <a:noFill/>
@@ -8218,12 +9561,80 @@
                 </a:solidFill>
                 <a:effectLst/>
                 <a:uFillTx/>
-                <a:latin typeface="ADLaM Display" panose="02010000000000000000" pitchFamily="2" charset="77"/>
-                <a:ea typeface="ADLaM Display" panose="02010000000000000000" pitchFamily="2" charset="77"/>
-                <a:cs typeface="ADLaM Display" panose="02010000000000000000" pitchFamily="2" charset="77"/>
+                <a:latin typeface="Script MT Bold" panose="03040602040607080904" pitchFamily="66" charset="0"/>
+                <a:ea typeface="ADLaM Display" panose="02010000000000000000" pitchFamily="2" charset="0"/>
+                <a:cs typeface="ADLaM Display" panose="02010000000000000000" pitchFamily="2" charset="0"/>
                 <a:sym typeface="Helvetica Neue"/>
               </a:rPr>
-              <a:t>FINAL DIA 2</a:t>
+              <a:t> </a:t>
+            </a:r>
+            <a:r>
+              <a:rPr kumimoji="0" lang="es-ES" sz="24300" b="0" i="0" u="none" strike="noStrike" cap="none" spc="0" normalizeH="0" baseline="0" dirty="0" err="1">
+                <a:ln>
+                  <a:noFill/>
+                </a:ln>
+                <a:solidFill>
+                  <a:schemeClr val="bg1"/>
+                </a:solidFill>
+                <a:effectLst/>
+                <a:uFillTx/>
+                <a:latin typeface="Script MT Bold" panose="03040602040607080904" pitchFamily="66" charset="0"/>
+                <a:ea typeface="ADLaM Display" panose="02010000000000000000" pitchFamily="2" charset="0"/>
+                <a:cs typeface="ADLaM Display" panose="02010000000000000000" pitchFamily="2" charset="0"/>
+                <a:sym typeface="Helvetica Neue"/>
+              </a:rPr>
+              <a:t>the</a:t>
+            </a:r>
+            <a:r>
+              <a:rPr kumimoji="0" lang="es-ES" sz="24300" b="0" i="0" u="none" strike="noStrike" cap="none" spc="0" normalizeH="0" baseline="0" dirty="0">
+                <a:ln>
+                  <a:noFill/>
+                </a:ln>
+                <a:solidFill>
+                  <a:schemeClr val="bg1"/>
+                </a:solidFill>
+                <a:effectLst/>
+                <a:uFillTx/>
+                <a:latin typeface="Script MT Bold" panose="03040602040607080904" pitchFamily="66" charset="0"/>
+                <a:ea typeface="ADLaM Display" panose="02010000000000000000" pitchFamily="2" charset="0"/>
+                <a:cs typeface="ADLaM Display" panose="02010000000000000000" pitchFamily="2" charset="0"/>
+                <a:sym typeface="Helvetica Neue"/>
+              </a:rPr>
+              <a:t> </a:t>
+            </a:r>
+            <a:r>
+              <a:rPr kumimoji="0" lang="es-ES" sz="24300" b="0" i="0" u="none" strike="noStrike" cap="none" spc="0" normalizeH="0" baseline="0" dirty="0" err="1">
+                <a:ln>
+                  <a:noFill/>
+                </a:ln>
+                <a:solidFill>
+                  <a:schemeClr val="bg1"/>
+                </a:solidFill>
+                <a:effectLst/>
+                <a:uFillTx/>
+                <a:latin typeface="Script MT Bold" panose="03040602040607080904" pitchFamily="66" charset="0"/>
+                <a:ea typeface="ADLaM Display" panose="02010000000000000000" pitchFamily="2" charset="0"/>
+                <a:cs typeface="ADLaM Display" panose="02010000000000000000" pitchFamily="2" charset="0"/>
+                <a:sym typeface="Helvetica Neue"/>
+              </a:rPr>
+              <a:t>day</a:t>
+            </a:r>
+            <a:r>
+              <a:rPr kumimoji="0" lang="es-ES" sz="24300" b="0" i="0" u="none" strike="noStrike" cap="none" spc="0" normalizeH="0" baseline="0" dirty="0">
+                <a:ln>
+                  <a:noFill/>
+                </a:ln>
+                <a:solidFill>
+                  <a:schemeClr val="bg1"/>
+                </a:solidFill>
+                <a:effectLst/>
+                <a:uFillTx/>
+                <a:latin typeface="Script MT Bold" panose="03040602040607080904" pitchFamily="66" charset="0"/>
+                <a:ea typeface="ADLaM Display" panose="02010000000000000000" pitchFamily="2" charset="0"/>
+                <a:cs typeface="ADLaM Display" panose="02010000000000000000" pitchFamily="2" charset="0"/>
+                <a:sym typeface="Helvetica Neue"/>
+              </a:rPr>
+              <a:t> 1</a:t>
             </a:r>
           </a:p>
         </p:txBody>
@@ -8231,7 +9642,7 @@
     </p:spTree>
     <p:extLst>
       <p:ext uri="{BB962C8B-B14F-4D97-AF65-F5344CB8AC3E}">
-        <p14:creationId xmlns:p14="http://schemas.microsoft.com/office/powerpoint/2010/main" val="4087996809"/>
+        <p14:creationId xmlns:p14="http://schemas.microsoft.com/office/powerpoint/2010/main" val="67953572"/>
       </p:ext>
     </p:extLst>
   </p:cSld>
@@ -8242,7 +9653,7 @@
 </p:sld>
 </file>
 
-<file path=ppt/slides/slide6.xml><?xml version="1.0" encoding="utf-8"?>
+<file path=ppt/slides/slide8.xml><?xml version="1.0" encoding="utf-8"?>
 <p:sld xmlns:a="http://schemas.openxmlformats.org/drawingml/2006/main" xmlns:r="http://schemas.openxmlformats.org/officeDocument/2006/relationships" xmlns:p="http://schemas.openxmlformats.org/presentationml/2006/main">
   <p:cSld>
     <p:spTree>
@@ -8250,7 +9661,7 @@
         <p:cNvPr id="1" name="">
           <a:extLst>
             <a:ext uri="{FF2B5EF4-FFF2-40B4-BE49-F238E27FC236}">
-              <a16:creationId xmlns:a16="http://schemas.microsoft.com/office/drawing/2014/main" id="{F4AA493B-9C69-CB37-346C-D65108D83DD4}"/>
+              <a16:creationId xmlns:a16="http://schemas.microsoft.com/office/drawing/2014/main" id="{09079EB2-75A3-2FE4-FCCE-8B1AC5512CD7}"/>
             </a:ext>
           </a:extLst>
         </p:cNvPr>
@@ -8267,10 +9678,10 @@
       </p:grpSpPr>
       <p:sp>
         <p:nvSpPr>
-          <p:cNvPr id="2" name="CuadroTexto 1">
+          <p:cNvPr id="26" name="CuadroTexto 25">
             <a:extLst>
               <a:ext uri="{FF2B5EF4-FFF2-40B4-BE49-F238E27FC236}">
-                <a16:creationId xmlns:a16="http://schemas.microsoft.com/office/drawing/2014/main" id="{3991B40E-BF69-6FAD-6CF5-83832F2287A7}"/>
+                <a16:creationId xmlns:a16="http://schemas.microsoft.com/office/drawing/2014/main" id="{618B768D-D6B3-9E58-88AC-A1EA30BAE42A}"/>
               </a:ext>
             </a:extLst>
           </p:cNvPr>
@@ -8279,78 +9690,165 @@
         </p:nvSpPr>
         <p:spPr>
           <a:xfrm>
-            <a:off x="2755900" y="4936961"/>
-            <a:ext cx="18872200" cy="3842077"/>
+            <a:off x="1417814" y="3879559"/>
+            <a:ext cx="1905444" cy="1719852"/>
           </a:xfrm>
           <a:prstGeom prst="rect">
             <a:avLst/>
           </a:prstGeom>
-          <a:noFill/>
-          <a:ln w="12700" cap="flat">
-            <a:noFill/>
-            <a:miter lim="400000"/>
-          </a:ln>
-          <a:effectLst/>
-          <a:sp3d/>
-        </p:spPr>
-        <p:style>
-          <a:lnRef idx="0">
-            <a:scrgbClr r="0" g="0" b="0"/>
-          </a:lnRef>
-          <a:fillRef idx="0">
-            <a:scrgbClr r="0" g="0" b="0"/>
-          </a:fillRef>
-          <a:effectRef idx="0">
-            <a:scrgbClr r="0" g="0" b="0"/>
-          </a:effectRef>
-          <a:fontRef idx="none"/>
-        </p:style>
+        </p:spPr>
         <p:txBody>
-          <a:bodyPr rot="0" spcFirstLastPara="1" vertOverflow="overflow" horzOverflow="overflow" vert="horz" wrap="square" lIns="50800" tIns="50800" rIns="50800" bIns="50800" numCol="1" spcCol="38100" rtlCol="0" anchor="ctr">
-            <a:spAutoFit/>
+          <a:bodyPr vert="horz" wrap="square" lIns="91440" tIns="45720" rIns="91440" bIns="45720" rtlCol="0">
+            <a:noAutofit/>
           </a:bodyPr>
           <a:lstStyle/>
           <a:p>
-            <a:pPr marL="0" marR="0" indent="0" algn="ctr" defTabSz="2438338" rtl="0" fontAlgn="auto" latinLnBrk="0" hangingPunct="0">
-              <a:lnSpc>
-                <a:spcPct val="100000"/>
-              </a:lnSpc>
-              <a:spcBef>
-                <a:spcPts val="0"/>
-              </a:spcBef>
-              <a:spcAft>
-                <a:spcPts val="0"/>
-              </a:spcAft>
-              <a:buClrTx/>
-              <a:buSzTx/>
-              <a:buFontTx/>
-              <a:buNone/>
-              <a:tabLst/>
-            </a:pPr>
-            <a:r>
-              <a:rPr kumimoji="0" lang="es-ES" sz="24300" b="0" i="0" u="none" strike="noStrike" cap="none" spc="0" normalizeH="0" baseline="0" dirty="0">
-                <a:ln>
-                  <a:noFill/>
-                </a:ln>
-                <a:solidFill>
-                  <a:schemeClr val="bg1"/>
-                </a:solidFill>
-                <a:effectLst/>
-                <a:uFillTx/>
-                <a:latin typeface="ADLaM Display" panose="02010000000000000000" pitchFamily="2" charset="77"/>
-                <a:ea typeface="ADLaM Display" panose="02010000000000000000" pitchFamily="2" charset="77"/>
-                <a:cs typeface="ADLaM Display" panose="02010000000000000000" pitchFamily="2" charset="77"/>
-                <a:sym typeface="Helvetica Neue"/>
+            <a:r>
+              <a:rPr lang="es-ES" sz="8800" b="1" dirty="0">
+                <a:solidFill>
+                  <a:srgbClr val="3479BB"/>
+                </a:solidFill>
+                <a:latin typeface="Montserrat" pitchFamily="2" charset="77"/>
               </a:rPr>
-              <a:t>FINAL DIA 3</a:t>
-            </a:r>
+              <a:t>1. </a:t>
+            </a:r>
+          </a:p>
+        </p:txBody>
+      </p:sp>
+      <p:sp>
+        <p:nvSpPr>
+          <p:cNvPr id="46" name="CuadroTexto 45">
+            <a:extLst>
+              <a:ext uri="{FF2B5EF4-FFF2-40B4-BE49-F238E27FC236}">
+                <a16:creationId xmlns:a16="http://schemas.microsoft.com/office/drawing/2014/main" id="{235214DA-E2B5-3350-EEC5-F8D12C4C48A2}"/>
+              </a:ext>
+            </a:extLst>
+          </p:cNvPr>
+          <p:cNvSpPr txBox="1"/>
+          <p:nvPr/>
+        </p:nvSpPr>
+        <p:spPr>
+          <a:xfrm>
+            <a:off x="2783840" y="7256664"/>
+            <a:ext cx="20706080" cy="1719852"/>
+          </a:xfrm>
+          <a:prstGeom prst="rect">
+            <a:avLst/>
+          </a:prstGeom>
+        </p:spPr>
+        <p:txBody>
+          <a:bodyPr vert="horz" wrap="square" lIns="91440" tIns="45720" rIns="91440" bIns="45720" rtlCol="0">
+            <a:noAutofit/>
+          </a:bodyPr>
+          <a:lstStyle/>
+          <a:p>
+            <a:pPr algn="r"/>
+            <a:r>
+              <a:rPr lang="es-ES" sz="11500" b="1" dirty="0">
+                <a:solidFill>
+                  <a:srgbClr val="F2F2F2"/>
+                </a:solidFill>
+                <a:latin typeface="Montserrat" pitchFamily="2" charset="77"/>
+              </a:rPr>
+              <a:t>5. </a:t>
+            </a:r>
+            <a:r>
+              <a:rPr lang="es-ES" sz="11500" b="1" dirty="0" err="1">
+                <a:solidFill>
+                  <a:srgbClr val="F2F2F2"/>
+                </a:solidFill>
+                <a:latin typeface="Montserrat" pitchFamily="2" charset="77"/>
+              </a:rPr>
+              <a:t>Boosting</a:t>
+            </a:r>
+            <a:r>
+              <a:rPr lang="es-ES" sz="11500" b="1" dirty="0">
+                <a:solidFill>
+                  <a:srgbClr val="F2F2F2"/>
+                </a:solidFill>
+                <a:latin typeface="Montserrat" pitchFamily="2" charset="77"/>
+              </a:rPr>
+              <a:t> </a:t>
+            </a:r>
+            <a:r>
+              <a:rPr lang="es-ES" sz="11500" b="1" dirty="0" err="1">
+                <a:solidFill>
+                  <a:srgbClr val="F2F2F2"/>
+                </a:solidFill>
+                <a:latin typeface="Montserrat" pitchFamily="2" charset="77"/>
+              </a:rPr>
+              <a:t>models</a:t>
+            </a:r>
+            <a:r>
+              <a:rPr lang="es-ES" sz="11500" b="1" dirty="0">
+                <a:solidFill>
+                  <a:srgbClr val="F2F2F2"/>
+                </a:solidFill>
+                <a:latin typeface="Montserrat" pitchFamily="2" charset="77"/>
+              </a:rPr>
+              <a:t>:</a:t>
+            </a:r>
+          </a:p>
+          <a:p>
+            <a:pPr algn="r"/>
+            <a:r>
+              <a:rPr lang="es-ES" sz="11500" b="1" dirty="0" err="1">
+                <a:solidFill>
+                  <a:srgbClr val="F2F2F2"/>
+                </a:solidFill>
+                <a:latin typeface="Montserrat" pitchFamily="2" charset="77"/>
+              </a:rPr>
+              <a:t>XGBoost</a:t>
+            </a:r>
+            <a:r>
+              <a:rPr lang="es-ES" sz="11500" b="1" dirty="0">
+                <a:solidFill>
+                  <a:srgbClr val="F2F2F2"/>
+                </a:solidFill>
+                <a:latin typeface="Montserrat" pitchFamily="2" charset="77"/>
+              </a:rPr>
+              <a:t>, </a:t>
+            </a:r>
+            <a:r>
+              <a:rPr lang="es-ES" sz="11500" b="1" dirty="0" err="1">
+                <a:solidFill>
+                  <a:srgbClr val="F2F2F2"/>
+                </a:solidFill>
+                <a:latin typeface="Montserrat" pitchFamily="2" charset="77"/>
+              </a:rPr>
+              <a:t>AdaBoost</a:t>
+            </a:r>
+            <a:r>
+              <a:rPr lang="es-ES" sz="11500" b="1" dirty="0">
+                <a:solidFill>
+                  <a:srgbClr val="F2F2F2"/>
+                </a:solidFill>
+                <a:latin typeface="Montserrat" pitchFamily="2" charset="77"/>
+              </a:rPr>
+              <a:t>, </a:t>
+            </a:r>
+            <a:r>
+              <a:rPr lang="es-ES" sz="11500" b="1" dirty="0" err="1">
+                <a:solidFill>
+                  <a:srgbClr val="F2F2F2"/>
+                </a:solidFill>
+                <a:latin typeface="Montserrat" pitchFamily="2" charset="77"/>
+              </a:rPr>
+              <a:t>CatBoost</a:t>
+            </a:r>
+            <a:endParaRPr lang="es-ES" sz="11500" b="1" dirty="0">
+              <a:solidFill>
+                <a:srgbClr val="F2F2F2"/>
+              </a:solidFill>
+              <a:latin typeface="Montserrat" pitchFamily="2" charset="77"/>
+            </a:endParaRPr>
           </a:p>
         </p:txBody>
       </p:sp>
     </p:spTree>
     <p:extLst>
       <p:ext uri="{BB962C8B-B14F-4D97-AF65-F5344CB8AC3E}">
-        <p14:creationId xmlns:p14="http://schemas.microsoft.com/office/powerpoint/2010/main" val="2638605457"/>
+        <p14:creationId xmlns:p14="http://schemas.microsoft.com/office/powerpoint/2010/main" val="3909224401"/>
       </p:ext>
     </p:extLst>
   </p:cSld>
@@ -8361,12 +9859,18 @@
 </p:sld>
 </file>
 
-<file path=ppt/slides/slide7.xml><?xml version="1.0" encoding="utf-8"?>
+<file path=ppt/slides/slide9.xml><?xml version="1.0" encoding="utf-8"?>
 <p:sld xmlns:a="http://schemas.openxmlformats.org/drawingml/2006/main" xmlns:r="http://schemas.openxmlformats.org/officeDocument/2006/relationships" xmlns:p="http://schemas.openxmlformats.org/presentationml/2006/main">
   <p:cSld>
     <p:spTree>
       <p:nvGrpSpPr>
-        <p:cNvPr id="1" name=""/>
+        <p:cNvPr id="1" name="">
+          <a:extLst>
+            <a:ext uri="{FF2B5EF4-FFF2-40B4-BE49-F238E27FC236}">
+              <a16:creationId xmlns:a16="http://schemas.microsoft.com/office/drawing/2014/main" id="{02046490-BBA7-5FA7-5B8B-E2D84F88BE0F}"/>
+            </a:ext>
+          </a:extLst>
+        </p:cNvPr>
         <p:cNvGrpSpPr/>
         <p:nvPr/>
       </p:nvGrpSpPr>
@@ -8380,39 +9884,107 @@
       </p:grpSpPr>
       <p:sp>
         <p:nvSpPr>
-          <p:cNvPr id="357" name="vicenc.fernandez@upc.edu"/>
-          <p:cNvSpPr txBox="1">
-            <a:spLocks noGrp="1"/>
-          </p:cNvSpPr>
-          <p:nvPr>
-            <p:ph type="title"/>
-          </p:nvPr>
+          <p:cNvPr id="26" name="CuadroTexto 25">
+            <a:extLst>
+              <a:ext uri="{FF2B5EF4-FFF2-40B4-BE49-F238E27FC236}">
+                <a16:creationId xmlns:a16="http://schemas.microsoft.com/office/drawing/2014/main" id="{9DB372C2-1EFC-9267-7FEB-A0B9F14A2ACE}"/>
+              </a:ext>
+            </a:extLst>
+          </p:cNvPr>
+          <p:cNvSpPr txBox="1"/>
+          <p:nvPr/>
         </p:nvSpPr>
         <p:spPr>
+          <a:xfrm>
+            <a:off x="1417814" y="3879559"/>
+            <a:ext cx="1905444" cy="1719852"/>
+          </a:xfrm>
           <a:prstGeom prst="rect">
             <a:avLst/>
           </a:prstGeom>
         </p:spPr>
         <p:txBody>
-          <a:bodyPr/>
-          <a:lstStyle>
-            <a:lvl1pPr>
-              <a:defRPr i="1"/>
-            </a:lvl1pPr>
-          </a:lstStyle>
-          <a:p>
-            <a:r>
-              <a:rPr lang="es-ES" dirty="0" err="1"/>
-              <a:t>sergi.ramirez</a:t>
-            </a:r>
-            <a:r>
-              <a:rPr dirty="0"/>
-              <a:t>@upc.edu</a:t>
+          <a:bodyPr vert="horz" wrap="square" lIns="91440" tIns="45720" rIns="91440" bIns="45720" rtlCol="0">
+            <a:noAutofit/>
+          </a:bodyPr>
+          <a:lstStyle/>
+          <a:p>
+            <a:r>
+              <a:rPr lang="es-ES" sz="8800" b="1" dirty="0">
+                <a:solidFill>
+                  <a:srgbClr val="3479BB"/>
+                </a:solidFill>
+                <a:latin typeface="Montserrat" pitchFamily="2" charset="77"/>
+              </a:rPr>
+              <a:t>1. </a:t>
+            </a:r>
+          </a:p>
+        </p:txBody>
+      </p:sp>
+      <p:sp>
+        <p:nvSpPr>
+          <p:cNvPr id="46" name="CuadroTexto 45">
+            <a:extLst>
+              <a:ext uri="{FF2B5EF4-FFF2-40B4-BE49-F238E27FC236}">
+                <a16:creationId xmlns:a16="http://schemas.microsoft.com/office/drawing/2014/main" id="{89E07715-59A9-641E-4408-39D81867300A}"/>
+              </a:ext>
+            </a:extLst>
+          </p:cNvPr>
+          <p:cNvSpPr txBox="1"/>
+          <p:nvPr/>
+        </p:nvSpPr>
+        <p:spPr>
+          <a:xfrm>
+            <a:off x="9527458" y="7256664"/>
+            <a:ext cx="13962462" cy="1719852"/>
+          </a:xfrm>
+          <a:prstGeom prst="rect">
+            <a:avLst/>
+          </a:prstGeom>
+        </p:spPr>
+        <p:txBody>
+          <a:bodyPr vert="horz" wrap="square" lIns="91440" tIns="45720" rIns="91440" bIns="45720" rtlCol="0">
+            <a:noAutofit/>
+          </a:bodyPr>
+          <a:lstStyle/>
+          <a:p>
+            <a:pPr algn="r"/>
+            <a:r>
+              <a:rPr lang="es-ES" sz="11500" b="1" dirty="0">
+                <a:solidFill>
+                  <a:srgbClr val="F2F2F2"/>
+                </a:solidFill>
+                <a:latin typeface="Montserrat" pitchFamily="2" charset="77"/>
+              </a:rPr>
+              <a:t>6. </a:t>
+            </a:r>
+            <a:r>
+              <a:rPr lang="es-ES" sz="11500" b="1" dirty="0" err="1">
+                <a:solidFill>
+                  <a:srgbClr val="F2F2F2"/>
+                </a:solidFill>
+                <a:latin typeface="Montserrat" pitchFamily="2" charset="77"/>
+              </a:rPr>
+              <a:t>Support</a:t>
+            </a:r>
+            <a:r>
+              <a:rPr lang="es-ES" sz="11500" b="1" dirty="0">
+                <a:solidFill>
+                  <a:srgbClr val="F2F2F2"/>
+                </a:solidFill>
+                <a:latin typeface="Montserrat" pitchFamily="2" charset="77"/>
+              </a:rPr>
+              <a:t> Vector Machine (SVM)</a:t>
             </a:r>
           </a:p>
         </p:txBody>
       </p:sp>
     </p:spTree>
+    <p:extLst>
+      <p:ext uri="{BB962C8B-B14F-4D97-AF65-F5344CB8AC3E}">
+        <p14:creationId xmlns:p14="http://schemas.microsoft.com/office/powerpoint/2010/main" val="916019761"/>
+      </p:ext>
+    </p:extLst>
   </p:cSld>
   <p:clrMapOvr>
     <a:masterClrMapping/>

</xml_diff>